<commit_message>
Sync con build local: fix proxy SSL LambdaTest, deteccion de Python en build.bat
- run.py: truststore.inject_into_ssl() antes de todo import, para que Python use
  la lista de certificados de Windows y no falle detras de proxies de oficina.
- build.bat: probar cada python de PATH y quedarse con el primero que responda
  version real, en vez de descartar WindowsApps a ciegas.
- Comparador de dealers: ajustes en runner y UI.
- Quitados los scripts de diagnostico de LambdaTest (eran pruebas, no parte de la app).
</commit_message>
<xml_diff>
--- a/Osocio_Form_Automation_Guia.pptx
+++ b/Osocio_Form_Automation_Guia.pptx
@@ -5,55 +5,55 @@
     <p:sldMasterId id="2147483648" r:id="rId1"/>
   </p:sldMasterIdLst>
   <p:sldIdLst>
-    <p:sldId id="256" r:id="rId7"/>
-    <p:sldId id="257" r:id="rId8"/>
-    <p:sldId id="258" r:id="rId9"/>
-    <p:sldId id="259" r:id="rId10"/>
-    <p:sldId id="260" r:id="rId11"/>
-    <p:sldId id="261" r:id="rId12"/>
-    <p:sldId id="262" r:id="rId13"/>
-    <p:sldId id="263" r:id="rId14"/>
-    <p:sldId id="264" r:id="rId15"/>
-    <p:sldId id="265" r:id="rId16"/>
-    <p:sldId id="266" r:id="rId17"/>
-    <p:sldId id="267" r:id="rId18"/>
-    <p:sldId id="268" r:id="rId19"/>
-    <p:sldId id="269" r:id="rId20"/>
-    <p:sldId id="270" r:id="rId21"/>
-    <p:sldId id="271" r:id="rId22"/>
-    <p:sldId id="272" r:id="rId23"/>
-    <p:sldId id="273" r:id="rId24"/>
-    <p:sldId id="274" r:id="rId25"/>
-    <p:sldId id="275" r:id="rId26"/>
-    <p:sldId id="276" r:id="rId27"/>
-    <p:sldId id="277" r:id="rId28"/>
-    <p:sldId id="278" r:id="rId29"/>
-    <p:sldId id="279" r:id="rId30"/>
-    <p:sldId id="280" r:id="rId31"/>
-    <p:sldId id="281" r:id="rId32"/>
-    <p:sldId id="282" r:id="rId33"/>
-    <p:sldId id="283" r:id="rId34"/>
-    <p:sldId id="284" r:id="rId35"/>
-    <p:sldId id="285" r:id="rId36"/>
-    <p:sldId id="286" r:id="rId37"/>
-    <p:sldId id="287" r:id="rId38"/>
-    <p:sldId id="288" r:id="rId39"/>
-    <p:sldId id="289" r:id="rId40"/>
-    <p:sldId id="290" r:id="rId41"/>
-    <p:sldId id="291" r:id="rId42"/>
-    <p:sldId id="292" r:id="rId43"/>
-    <p:sldId id="293" r:id="rId44"/>
-    <p:sldId id="294" r:id="rId45"/>
-    <p:sldId id="295" r:id="rId46"/>
-    <p:sldId id="296" r:id="rId47"/>
-    <p:sldId id="297" r:id="rId48"/>
-    <p:sldId id="298" r:id="rId49"/>
-    <p:sldId id="299" r:id="rId50"/>
-    <p:sldId id="300" r:id="rId51"/>
-    <p:sldId id="301" r:id="rId52"/>
-    <p:sldId id="302" r:id="rId53"/>
+    <p:sldId id="256" r:id="rId2"/>
+    <p:sldId id="257" r:id="rId3"/>
+    <p:sldId id="258" r:id="rId4"/>
+    <p:sldId id="259" r:id="rId5"/>
+    <p:sldId id="260" r:id="rId6"/>
+    <p:sldId id="261" r:id="rId7"/>
+    <p:sldId id="262" r:id="rId8"/>
+    <p:sldId id="263" r:id="rId9"/>
+    <p:sldId id="264" r:id="rId10"/>
+    <p:sldId id="265" r:id="rId11"/>
+    <p:sldId id="266" r:id="rId12"/>
+    <p:sldId id="267" r:id="rId13"/>
+    <p:sldId id="268" r:id="rId14"/>
+    <p:sldId id="269" r:id="rId15"/>
+    <p:sldId id="270" r:id="rId16"/>
+    <p:sldId id="271" r:id="rId17"/>
+    <p:sldId id="272" r:id="rId18"/>
+    <p:sldId id="273" r:id="rId19"/>
+    <p:sldId id="274" r:id="rId20"/>
+    <p:sldId id="275" r:id="rId21"/>
+    <p:sldId id="276" r:id="rId22"/>
+    <p:sldId id="277" r:id="rId23"/>
+    <p:sldId id="278" r:id="rId24"/>
+    <p:sldId id="279" r:id="rId25"/>
+    <p:sldId id="280" r:id="rId26"/>
+    <p:sldId id="281" r:id="rId27"/>
+    <p:sldId id="282" r:id="rId28"/>
+    <p:sldId id="283" r:id="rId29"/>
+    <p:sldId id="284" r:id="rId30"/>
+    <p:sldId id="285" r:id="rId31"/>
+    <p:sldId id="286" r:id="rId32"/>
+    <p:sldId id="287" r:id="rId33"/>
+    <p:sldId id="288" r:id="rId34"/>
+    <p:sldId id="289" r:id="rId35"/>
+    <p:sldId id="290" r:id="rId36"/>
+    <p:sldId id="291" r:id="rId37"/>
+    <p:sldId id="292" r:id="rId38"/>
+    <p:sldId id="293" r:id="rId39"/>
+    <p:sldId id="294" r:id="rId40"/>
+    <p:sldId id="295" r:id="rId41"/>
+    <p:sldId id="296" r:id="rId42"/>
+    <p:sldId id="297" r:id="rId43"/>
+    <p:sldId id="298" r:id="rId44"/>
+    <p:sldId id="299" r:id="rId45"/>
+    <p:sldId id="300" r:id="rId46"/>
+    <p:sldId id="301" r:id="rId47"/>
+    <p:sldId id="302" r:id="rId48"/>
   </p:sldIdLst>
-  <p:sldSz cx="12191695" cy="6858000" type="screen4x3"/>
+  <p:sldSz cx="12192000" cy="6858000"/>
   <p:notesSz cx="6858000" cy="9144000"/>
   <p:defaultTextStyle>
     <a:defPPr>
@@ -150,7 +150,67 @@
       </a:defRPr>
     </a:lvl9pPr>
   </p:defaultTextStyle>
+  <p:extLst>
+    <p:ext uri="{EFAFB233-063F-42B5-8137-9DF3F51BA10A}">
+      <p15:sldGuideLst xmlns:p15="http://schemas.microsoft.com/office/powerpoint/2012/main">
+        <p15:guide id="1" orient="horz" pos="2160">
+          <p15:clr>
+            <a:srgbClr val="A4A3A4"/>
+          </p15:clr>
+        </p15:guide>
+        <p15:guide id="2" pos="2880">
+          <p15:clr>
+            <a:srgbClr val="A4A3A4"/>
+          </p15:clr>
+        </p15:guide>
+      </p15:sldGuideLst>
+    </p:ext>
+  </p:extLst>
 </p:presentation>
+</file>
+
+<file path=ppt/changesInfos/changesInfo1.xml><?xml version="1.0" encoding="utf-8"?>
+<pc:chgInfo xmlns:a="http://schemas.openxmlformats.org/drawingml/2006/main" xmlns:r="http://schemas.openxmlformats.org/officeDocument/2006/relationships" xmlns:ac="http://schemas.microsoft.com/office/drawing/2013/main/command" xmlns:pc="http://schemas.microsoft.com/office/powerpoint/2013/main/command">
+  <pc:docChgLst>
+    <pc:chgData name="Elian Zás Herrera (Omnicom)" userId="77b7ef70-7c20-4270-9606-2cc9413c673a" providerId="ADAL" clId="{D32F1A1B-CEDE-4E96-A05D-0228BBA7F826}"/>
+    <pc:docChg chg="mod modSld modMainMaster">
+      <pc:chgData name="Elian Zás Herrera (Omnicom)" userId="77b7ef70-7c20-4270-9606-2cc9413c673a" providerId="ADAL" clId="{D32F1A1B-CEDE-4E96-A05D-0228BBA7F826}" dt="2026-07-21T16:41:54.402" v="5" actId="33475"/>
+      <pc:docMkLst>
+        <pc:docMk/>
+      </pc:docMkLst>
+      <pc:sldChg chg="modSp mod">
+        <pc:chgData name="Elian Zás Herrera (Omnicom)" userId="77b7ef70-7c20-4270-9606-2cc9413c673a" providerId="ADAL" clId="{D32F1A1B-CEDE-4E96-A05D-0228BBA7F826}" dt="2026-07-21T16:41:46.005" v="3" actId="20577"/>
+        <pc:sldMkLst>
+          <pc:docMk/>
+          <pc:sldMk cId="0" sldId="262"/>
+        </pc:sldMkLst>
+        <pc:spChg chg="mod">
+          <ac:chgData name="Elian Zás Herrera (Omnicom)" userId="77b7ef70-7c20-4270-9606-2cc9413c673a" providerId="ADAL" clId="{D32F1A1B-CEDE-4E96-A05D-0228BBA7F826}" dt="2026-07-21T16:41:46.005" v="3" actId="20577"/>
+          <ac:spMkLst>
+            <pc:docMk/>
+            <pc:sldMk cId="0" sldId="262"/>
+            <ac:spMk id="4" creationId="{00000000-0000-0000-0000-000000000000}"/>
+          </ac:spMkLst>
+        </pc:spChg>
+      </pc:sldChg>
+      <pc:sldMasterChg chg="addSp mod">
+        <pc:chgData name="Elian Zás Herrera (Omnicom)" userId="77b7ef70-7c20-4270-9606-2cc9413c673a" providerId="ADAL" clId="{D32F1A1B-CEDE-4E96-A05D-0228BBA7F826}" dt="2026-07-21T16:41:54.402" v="4" actId="33475"/>
+        <pc:sldMasterMkLst>
+          <pc:docMk/>
+          <pc:sldMasterMk cId="2209977519" sldId="2147483648"/>
+        </pc:sldMasterMkLst>
+        <pc:spChg chg="add">
+          <ac:chgData name="Elian Zás Herrera (Omnicom)" userId="77b7ef70-7c20-4270-9606-2cc9413c673a" providerId="ADAL" clId="{D32F1A1B-CEDE-4E96-A05D-0228BBA7F826}" dt="2026-07-21T16:41:54.402" v="4" actId="33475"/>
+          <ac:spMkLst>
+            <pc:docMk/>
+            <pc:sldMasterMk cId="2209977519" sldId="2147483648"/>
+            <ac:spMk id="8" creationId="{A2C00982-A475-5FBC-BDDF-47383EED8AC7}"/>
+          </ac:spMkLst>
+        </pc:spChg>
+      </pc:sldMasterChg>
+    </pc:docChg>
+  </pc:docChgLst>
+</pc:chgInfo>
 </file>
 
 <file path=ppt/slideLayouts/slideLayout1.xml><?xml version="1.0" encoding="utf-8"?>
@@ -191,10 +251,9 @@
           <a:lstStyle/>
           <a:p>
             <a:r>
-              <a:rPr lang="en-US" smtClean="0"/>
+              <a:rPr lang="en-US"/>
               <a:t>Click to edit Master title style</a:t>
             </a:r>
-            <a:endParaRPr lang="en-US"/>
           </a:p>
         </p:txBody>
       </p:sp>
@@ -310,10 +369,9 @@
           </a:lstStyle>
           <a:p>
             <a:r>
-              <a:rPr lang="en-US" smtClean="0"/>
+              <a:rPr lang="en-US"/>
               <a:t>Click to edit Master subtitle style</a:t>
             </a:r>
-            <a:endParaRPr lang="en-US"/>
           </a:p>
         </p:txBody>
       </p:sp>
@@ -334,7 +392,7 @@
           <a:p>
             <a:fld id="{5BCAD085-E8A6-8845-BD4E-CB4CCA059FC4}" type="datetimeFigureOut">
               <a:rPr lang="en-US" smtClean="0"/>
-              <a:t>1/27/13</a:t>
+              <a:t>7/21/2026</a:t>
             </a:fld>
             <a:endParaRPr lang="en-US"/>
           </a:p>
@@ -376,7 +434,7 @@
           <a:p>
             <a:fld id="{C1FF6DA9-008F-8B48-92A6-B652298478BF}" type="slidenum">
               <a:rPr lang="en-US" smtClean="0"/>
-              <a:t>‹#›</a:t>
+              <a:t>‹Nº›</a:t>
             </a:fld>
             <a:endParaRPr lang="en-US"/>
           </a:p>
@@ -428,10 +486,9 @@
           <a:lstStyle/>
           <a:p>
             <a:r>
-              <a:rPr lang="en-US" smtClean="0"/>
+              <a:rPr lang="en-US"/>
               <a:t>Click to edit Master title style</a:t>
             </a:r>
-            <a:endParaRPr lang="en-US"/>
           </a:p>
         </p:txBody>
       </p:sp>
@@ -452,38 +509,37 @@
           <a:p>
             <a:pPr lvl="0"/>
             <a:r>
-              <a:rPr lang="en-US" smtClean="0"/>
+              <a:rPr lang="en-US"/>
               <a:t>Click to edit Master text styles</a:t>
             </a:r>
           </a:p>
           <a:p>
             <a:pPr lvl="1"/>
             <a:r>
-              <a:rPr lang="en-US" smtClean="0"/>
+              <a:rPr lang="en-US"/>
               <a:t>Second level</a:t>
             </a:r>
           </a:p>
           <a:p>
             <a:pPr lvl="2"/>
             <a:r>
-              <a:rPr lang="en-US" smtClean="0"/>
+              <a:rPr lang="en-US"/>
               <a:t>Third level</a:t>
             </a:r>
           </a:p>
           <a:p>
             <a:pPr lvl="3"/>
             <a:r>
-              <a:rPr lang="en-US" smtClean="0"/>
+              <a:rPr lang="en-US"/>
               <a:t>Fourth level</a:t>
             </a:r>
           </a:p>
           <a:p>
             <a:pPr lvl="4"/>
             <a:r>
-              <a:rPr lang="en-US" smtClean="0"/>
+              <a:rPr lang="en-US"/>
               <a:t>Fifth level</a:t>
             </a:r>
-            <a:endParaRPr lang="en-US"/>
           </a:p>
         </p:txBody>
       </p:sp>
@@ -504,7 +560,7 @@
           <a:p>
             <a:fld id="{5BCAD085-E8A6-8845-BD4E-CB4CCA059FC4}" type="datetimeFigureOut">
               <a:rPr lang="en-US" smtClean="0"/>
-              <a:t>1/27/13</a:t>
+              <a:t>7/21/2026</a:t>
             </a:fld>
             <a:endParaRPr lang="en-US"/>
           </a:p>
@@ -546,7 +602,7 @@
           <a:p>
             <a:fld id="{C1FF6DA9-008F-8B48-92A6-B652298478BF}" type="slidenum">
               <a:rPr lang="en-US" smtClean="0"/>
-              <a:t>‹#›</a:t>
+              <a:t>‹Nº›</a:t>
             </a:fld>
             <a:endParaRPr lang="en-US"/>
           </a:p>
@@ -603,10 +659,9 @@
           <a:lstStyle/>
           <a:p>
             <a:r>
-              <a:rPr lang="en-US" smtClean="0"/>
+              <a:rPr lang="en-US"/>
               <a:t>Click to edit Master title style</a:t>
             </a:r>
-            <a:endParaRPr lang="en-US"/>
           </a:p>
         </p:txBody>
       </p:sp>
@@ -632,38 +687,37 @@
           <a:p>
             <a:pPr lvl="0"/>
             <a:r>
-              <a:rPr lang="en-US" smtClean="0"/>
+              <a:rPr lang="en-US"/>
               <a:t>Click to edit Master text styles</a:t>
             </a:r>
           </a:p>
           <a:p>
             <a:pPr lvl="1"/>
             <a:r>
-              <a:rPr lang="en-US" smtClean="0"/>
+              <a:rPr lang="en-US"/>
               <a:t>Second level</a:t>
             </a:r>
           </a:p>
           <a:p>
             <a:pPr lvl="2"/>
             <a:r>
-              <a:rPr lang="en-US" smtClean="0"/>
+              <a:rPr lang="en-US"/>
               <a:t>Third level</a:t>
             </a:r>
           </a:p>
           <a:p>
             <a:pPr lvl="3"/>
             <a:r>
-              <a:rPr lang="en-US" smtClean="0"/>
+              <a:rPr lang="en-US"/>
               <a:t>Fourth level</a:t>
             </a:r>
           </a:p>
           <a:p>
             <a:pPr lvl="4"/>
             <a:r>
-              <a:rPr lang="en-US" smtClean="0"/>
+              <a:rPr lang="en-US"/>
               <a:t>Fifth level</a:t>
             </a:r>
-            <a:endParaRPr lang="en-US"/>
           </a:p>
         </p:txBody>
       </p:sp>
@@ -684,7 +738,7 @@
           <a:p>
             <a:fld id="{5BCAD085-E8A6-8845-BD4E-CB4CCA059FC4}" type="datetimeFigureOut">
               <a:rPr lang="en-US" smtClean="0"/>
-              <a:t>1/27/13</a:t>
+              <a:t>7/21/2026</a:t>
             </a:fld>
             <a:endParaRPr lang="en-US"/>
           </a:p>
@@ -726,7 +780,7 @@
           <a:p>
             <a:fld id="{C1FF6DA9-008F-8B48-92A6-B652298478BF}" type="slidenum">
               <a:rPr lang="en-US" smtClean="0"/>
-              <a:t>‹#›</a:t>
+              <a:t>‹Nº›</a:t>
             </a:fld>
             <a:endParaRPr lang="en-US"/>
           </a:p>
@@ -778,10 +832,9 @@
           <a:lstStyle/>
           <a:p>
             <a:r>
-              <a:rPr lang="en-US" smtClean="0"/>
+              <a:rPr lang="en-US"/>
               <a:t>Click to edit Master title style</a:t>
             </a:r>
-            <a:endParaRPr lang="en-US"/>
           </a:p>
         </p:txBody>
       </p:sp>
@@ -802,38 +855,37 @@
           <a:p>
             <a:pPr lvl="0"/>
             <a:r>
-              <a:rPr lang="en-US" smtClean="0"/>
+              <a:rPr lang="en-US"/>
               <a:t>Click to edit Master text styles</a:t>
             </a:r>
           </a:p>
           <a:p>
             <a:pPr lvl="1"/>
             <a:r>
-              <a:rPr lang="en-US" smtClean="0"/>
+              <a:rPr lang="en-US"/>
               <a:t>Second level</a:t>
             </a:r>
           </a:p>
           <a:p>
             <a:pPr lvl="2"/>
             <a:r>
-              <a:rPr lang="en-US" smtClean="0"/>
+              <a:rPr lang="en-US"/>
               <a:t>Third level</a:t>
             </a:r>
           </a:p>
           <a:p>
             <a:pPr lvl="3"/>
             <a:r>
-              <a:rPr lang="en-US" smtClean="0"/>
+              <a:rPr lang="en-US"/>
               <a:t>Fourth level</a:t>
             </a:r>
           </a:p>
           <a:p>
             <a:pPr lvl="4"/>
             <a:r>
-              <a:rPr lang="en-US" smtClean="0"/>
+              <a:rPr lang="en-US"/>
               <a:t>Fifth level</a:t>
             </a:r>
-            <a:endParaRPr lang="en-US"/>
           </a:p>
         </p:txBody>
       </p:sp>
@@ -854,7 +906,7 @@
           <a:p>
             <a:fld id="{5BCAD085-E8A6-8845-BD4E-CB4CCA059FC4}" type="datetimeFigureOut">
               <a:rPr lang="en-US" smtClean="0"/>
-              <a:t>1/27/13</a:t>
+              <a:t>7/21/2026</a:t>
             </a:fld>
             <a:endParaRPr lang="en-US"/>
           </a:p>
@@ -896,7 +948,7 @@
           <a:p>
             <a:fld id="{C1FF6DA9-008F-8B48-92A6-B652298478BF}" type="slidenum">
               <a:rPr lang="en-US" smtClean="0"/>
-              <a:t>‹#›</a:t>
+              <a:t>‹Nº›</a:t>
             </a:fld>
             <a:endParaRPr lang="en-US"/>
           </a:p>
@@ -957,10 +1009,9 @@
           </a:lstStyle>
           <a:p>
             <a:r>
-              <a:rPr lang="en-US" smtClean="0"/>
+              <a:rPr lang="en-US"/>
               <a:t>Click to edit Master title style</a:t>
             </a:r>
-            <a:endParaRPr lang="en-US"/>
           </a:p>
         </p:txBody>
       </p:sp>
@@ -1077,7 +1128,7 @@
           <a:p>
             <a:pPr lvl="0"/>
             <a:r>
-              <a:rPr lang="en-US" smtClean="0"/>
+              <a:rPr lang="en-US"/>
               <a:t>Click to edit Master text styles</a:t>
             </a:r>
           </a:p>
@@ -1100,7 +1151,7 @@
           <a:p>
             <a:fld id="{5BCAD085-E8A6-8845-BD4E-CB4CCA059FC4}" type="datetimeFigureOut">
               <a:rPr lang="en-US" smtClean="0"/>
-              <a:t>1/27/13</a:t>
+              <a:t>7/21/2026</a:t>
             </a:fld>
             <a:endParaRPr lang="en-US"/>
           </a:p>
@@ -1142,7 +1193,7 @@
           <a:p>
             <a:fld id="{C1FF6DA9-008F-8B48-92A6-B652298478BF}" type="slidenum">
               <a:rPr lang="en-US" smtClean="0"/>
-              <a:t>‹#›</a:t>
+              <a:t>‹Nº›</a:t>
             </a:fld>
             <a:endParaRPr lang="en-US"/>
           </a:p>
@@ -1194,10 +1245,9 @@
           <a:lstStyle/>
           <a:p>
             <a:r>
-              <a:rPr lang="en-US" smtClean="0"/>
+              <a:rPr lang="en-US"/>
               <a:t>Click to edit Master title style</a:t>
             </a:r>
-            <a:endParaRPr lang="en-US"/>
           </a:p>
         </p:txBody>
       </p:sp>
@@ -1251,38 +1301,37 @@
           <a:p>
             <a:pPr lvl="0"/>
             <a:r>
-              <a:rPr lang="en-US" smtClean="0"/>
+              <a:rPr lang="en-US"/>
               <a:t>Click to edit Master text styles</a:t>
             </a:r>
           </a:p>
           <a:p>
             <a:pPr lvl="1"/>
             <a:r>
-              <a:rPr lang="en-US" smtClean="0"/>
+              <a:rPr lang="en-US"/>
               <a:t>Second level</a:t>
             </a:r>
           </a:p>
           <a:p>
             <a:pPr lvl="2"/>
             <a:r>
-              <a:rPr lang="en-US" smtClean="0"/>
+              <a:rPr lang="en-US"/>
               <a:t>Third level</a:t>
             </a:r>
           </a:p>
           <a:p>
             <a:pPr lvl="3"/>
             <a:r>
-              <a:rPr lang="en-US" smtClean="0"/>
+              <a:rPr lang="en-US"/>
               <a:t>Fourth level</a:t>
             </a:r>
           </a:p>
           <a:p>
             <a:pPr lvl="4"/>
             <a:r>
-              <a:rPr lang="en-US" smtClean="0"/>
+              <a:rPr lang="en-US"/>
               <a:t>Fifth level</a:t>
             </a:r>
-            <a:endParaRPr lang="en-US"/>
           </a:p>
         </p:txBody>
       </p:sp>
@@ -1336,38 +1385,37 @@
           <a:p>
             <a:pPr lvl="0"/>
             <a:r>
-              <a:rPr lang="en-US" smtClean="0"/>
+              <a:rPr lang="en-US"/>
               <a:t>Click to edit Master text styles</a:t>
             </a:r>
           </a:p>
           <a:p>
             <a:pPr lvl="1"/>
             <a:r>
-              <a:rPr lang="en-US" smtClean="0"/>
+              <a:rPr lang="en-US"/>
               <a:t>Second level</a:t>
             </a:r>
           </a:p>
           <a:p>
             <a:pPr lvl="2"/>
             <a:r>
-              <a:rPr lang="en-US" smtClean="0"/>
+              <a:rPr lang="en-US"/>
               <a:t>Third level</a:t>
             </a:r>
           </a:p>
           <a:p>
             <a:pPr lvl="3"/>
             <a:r>
-              <a:rPr lang="en-US" smtClean="0"/>
+              <a:rPr lang="en-US"/>
               <a:t>Fourth level</a:t>
             </a:r>
           </a:p>
           <a:p>
             <a:pPr lvl="4"/>
             <a:r>
-              <a:rPr lang="en-US" smtClean="0"/>
+              <a:rPr lang="en-US"/>
               <a:t>Fifth level</a:t>
             </a:r>
-            <a:endParaRPr lang="en-US"/>
           </a:p>
         </p:txBody>
       </p:sp>
@@ -1388,7 +1436,7 @@
           <a:p>
             <a:fld id="{5BCAD085-E8A6-8845-BD4E-CB4CCA059FC4}" type="datetimeFigureOut">
               <a:rPr lang="en-US" smtClean="0"/>
-              <a:t>1/27/13</a:t>
+              <a:t>7/21/2026</a:t>
             </a:fld>
             <a:endParaRPr lang="en-US"/>
           </a:p>
@@ -1430,7 +1478,7 @@
           <a:p>
             <a:fld id="{C1FF6DA9-008F-8B48-92A6-B652298478BF}" type="slidenum">
               <a:rPr lang="en-US" smtClean="0"/>
-              <a:t>‹#›</a:t>
+              <a:t>‹Nº›</a:t>
             </a:fld>
             <a:endParaRPr lang="en-US"/>
           </a:p>
@@ -1486,10 +1534,9 @@
           </a:lstStyle>
           <a:p>
             <a:r>
-              <a:rPr lang="en-US" smtClean="0"/>
+              <a:rPr lang="en-US"/>
               <a:t>Click to edit Master title style</a:t>
             </a:r>
-            <a:endParaRPr lang="en-US"/>
           </a:p>
         </p:txBody>
       </p:sp>
@@ -1552,7 +1599,7 @@
           <a:p>
             <a:pPr lvl="0"/>
             <a:r>
-              <a:rPr lang="en-US" smtClean="0"/>
+              <a:rPr lang="en-US"/>
               <a:t>Click to edit Master text styles</a:t>
             </a:r>
           </a:p>
@@ -1608,38 +1655,37 @@
           <a:p>
             <a:pPr lvl="0"/>
             <a:r>
-              <a:rPr lang="en-US" smtClean="0"/>
+              <a:rPr lang="en-US"/>
               <a:t>Click to edit Master text styles</a:t>
             </a:r>
           </a:p>
           <a:p>
             <a:pPr lvl="1"/>
             <a:r>
-              <a:rPr lang="en-US" smtClean="0"/>
+              <a:rPr lang="en-US"/>
               <a:t>Second level</a:t>
             </a:r>
           </a:p>
           <a:p>
             <a:pPr lvl="2"/>
             <a:r>
-              <a:rPr lang="en-US" smtClean="0"/>
+              <a:rPr lang="en-US"/>
               <a:t>Third level</a:t>
             </a:r>
           </a:p>
           <a:p>
             <a:pPr lvl="3"/>
             <a:r>
-              <a:rPr lang="en-US" smtClean="0"/>
+              <a:rPr lang="en-US"/>
               <a:t>Fourth level</a:t>
             </a:r>
           </a:p>
           <a:p>
             <a:pPr lvl="4"/>
             <a:r>
-              <a:rPr lang="en-US" smtClean="0"/>
+              <a:rPr lang="en-US"/>
               <a:t>Fifth level</a:t>
             </a:r>
-            <a:endParaRPr lang="en-US"/>
           </a:p>
         </p:txBody>
       </p:sp>
@@ -1702,7 +1748,7 @@
           <a:p>
             <a:pPr lvl="0"/>
             <a:r>
-              <a:rPr lang="en-US" smtClean="0"/>
+              <a:rPr lang="en-US"/>
               <a:t>Click to edit Master text styles</a:t>
             </a:r>
           </a:p>
@@ -1758,38 +1804,37 @@
           <a:p>
             <a:pPr lvl="0"/>
             <a:r>
-              <a:rPr lang="en-US" smtClean="0"/>
+              <a:rPr lang="en-US"/>
               <a:t>Click to edit Master text styles</a:t>
             </a:r>
           </a:p>
           <a:p>
             <a:pPr lvl="1"/>
             <a:r>
-              <a:rPr lang="en-US" smtClean="0"/>
+              <a:rPr lang="en-US"/>
               <a:t>Second level</a:t>
             </a:r>
           </a:p>
           <a:p>
             <a:pPr lvl="2"/>
             <a:r>
-              <a:rPr lang="en-US" smtClean="0"/>
+              <a:rPr lang="en-US"/>
               <a:t>Third level</a:t>
             </a:r>
           </a:p>
           <a:p>
             <a:pPr lvl="3"/>
             <a:r>
-              <a:rPr lang="en-US" smtClean="0"/>
+              <a:rPr lang="en-US"/>
               <a:t>Fourth level</a:t>
             </a:r>
           </a:p>
           <a:p>
             <a:pPr lvl="4"/>
             <a:r>
-              <a:rPr lang="en-US" smtClean="0"/>
+              <a:rPr lang="en-US"/>
               <a:t>Fifth level</a:t>
             </a:r>
-            <a:endParaRPr lang="en-US"/>
           </a:p>
         </p:txBody>
       </p:sp>
@@ -1810,7 +1855,7 @@
           <a:p>
             <a:fld id="{5BCAD085-E8A6-8845-BD4E-CB4CCA059FC4}" type="datetimeFigureOut">
               <a:rPr lang="en-US" smtClean="0"/>
-              <a:t>1/27/13</a:t>
+              <a:t>7/21/2026</a:t>
             </a:fld>
             <a:endParaRPr lang="en-US"/>
           </a:p>
@@ -1852,7 +1897,7 @@
           <a:p>
             <a:fld id="{C1FF6DA9-008F-8B48-92A6-B652298478BF}" type="slidenum">
               <a:rPr lang="en-US" smtClean="0"/>
-              <a:t>‹#›</a:t>
+              <a:t>‹Nº›</a:t>
             </a:fld>
             <a:endParaRPr lang="en-US"/>
           </a:p>
@@ -1904,10 +1949,9 @@
           <a:lstStyle/>
           <a:p>
             <a:r>
-              <a:rPr lang="en-US" smtClean="0"/>
+              <a:rPr lang="en-US"/>
               <a:t>Click to edit Master title style</a:t>
             </a:r>
-            <a:endParaRPr lang="en-US"/>
           </a:p>
         </p:txBody>
       </p:sp>
@@ -1928,7 +1972,7 @@
           <a:p>
             <a:fld id="{5BCAD085-E8A6-8845-BD4E-CB4CCA059FC4}" type="datetimeFigureOut">
               <a:rPr lang="en-US" smtClean="0"/>
-              <a:t>1/27/13</a:t>
+              <a:t>7/21/2026</a:t>
             </a:fld>
             <a:endParaRPr lang="en-US"/>
           </a:p>
@@ -1970,7 +2014,7 @@
           <a:p>
             <a:fld id="{C1FF6DA9-008F-8B48-92A6-B652298478BF}" type="slidenum">
               <a:rPr lang="en-US" smtClean="0"/>
-              <a:t>‹#›</a:t>
+              <a:t>‹Nº›</a:t>
             </a:fld>
             <a:endParaRPr lang="en-US"/>
           </a:p>
@@ -2023,7 +2067,7 @@
           <a:p>
             <a:fld id="{5BCAD085-E8A6-8845-BD4E-CB4CCA059FC4}" type="datetimeFigureOut">
               <a:rPr lang="en-US" smtClean="0"/>
-              <a:t>1/27/13</a:t>
+              <a:t>7/21/2026</a:t>
             </a:fld>
             <a:endParaRPr lang="en-US"/>
           </a:p>
@@ -2065,7 +2109,7 @@
           <a:p>
             <a:fld id="{C1FF6DA9-008F-8B48-92A6-B652298478BF}" type="slidenum">
               <a:rPr lang="en-US" smtClean="0"/>
-              <a:t>‹#›</a:t>
+              <a:t>‹Nº›</a:t>
             </a:fld>
             <a:endParaRPr lang="en-US"/>
           </a:p>
@@ -2126,10 +2170,9 @@
           </a:lstStyle>
           <a:p>
             <a:r>
-              <a:rPr lang="en-US" smtClean="0"/>
+              <a:rPr lang="en-US"/>
               <a:t>Click to edit Master title style</a:t>
             </a:r>
-            <a:endParaRPr lang="en-US"/>
           </a:p>
         </p:txBody>
       </p:sp>
@@ -2183,38 +2226,37 @@
           <a:p>
             <a:pPr lvl="0"/>
             <a:r>
-              <a:rPr lang="en-US" smtClean="0"/>
+              <a:rPr lang="en-US"/>
               <a:t>Click to edit Master text styles</a:t>
             </a:r>
           </a:p>
           <a:p>
             <a:pPr lvl="1"/>
             <a:r>
-              <a:rPr lang="en-US" smtClean="0"/>
+              <a:rPr lang="en-US"/>
               <a:t>Second level</a:t>
             </a:r>
           </a:p>
           <a:p>
             <a:pPr lvl="2"/>
             <a:r>
-              <a:rPr lang="en-US" smtClean="0"/>
+              <a:rPr lang="en-US"/>
               <a:t>Third level</a:t>
             </a:r>
           </a:p>
           <a:p>
             <a:pPr lvl="3"/>
             <a:r>
-              <a:rPr lang="en-US" smtClean="0"/>
+              <a:rPr lang="en-US"/>
               <a:t>Fourth level</a:t>
             </a:r>
           </a:p>
           <a:p>
             <a:pPr lvl="4"/>
             <a:r>
-              <a:rPr lang="en-US" smtClean="0"/>
+              <a:rPr lang="en-US"/>
               <a:t>Fifth level</a:t>
             </a:r>
-            <a:endParaRPr lang="en-US"/>
           </a:p>
         </p:txBody>
       </p:sp>
@@ -2277,7 +2319,7 @@
           <a:p>
             <a:pPr lvl="0"/>
             <a:r>
-              <a:rPr lang="en-US" smtClean="0"/>
+              <a:rPr lang="en-US"/>
               <a:t>Click to edit Master text styles</a:t>
             </a:r>
           </a:p>
@@ -2300,7 +2342,7 @@
           <a:p>
             <a:fld id="{5BCAD085-E8A6-8845-BD4E-CB4CCA059FC4}" type="datetimeFigureOut">
               <a:rPr lang="en-US" smtClean="0"/>
-              <a:t>1/27/13</a:t>
+              <a:t>7/21/2026</a:t>
             </a:fld>
             <a:endParaRPr lang="en-US"/>
           </a:p>
@@ -2342,7 +2384,7 @@
           <a:p>
             <a:fld id="{C1FF6DA9-008F-8B48-92A6-B652298478BF}" type="slidenum">
               <a:rPr lang="en-US" smtClean="0"/>
-              <a:t>‹#›</a:t>
+              <a:t>‹Nº›</a:t>
             </a:fld>
             <a:endParaRPr lang="en-US"/>
           </a:p>
@@ -2403,10 +2445,9 @@
           </a:lstStyle>
           <a:p>
             <a:r>
-              <a:rPr lang="en-US" smtClean="0"/>
+              <a:rPr lang="en-US"/>
               <a:t>Click to edit Master title style</a:t>
             </a:r>
-            <a:endParaRPr lang="en-US"/>
           </a:p>
         </p:txBody>
       </p:sp>
@@ -2530,7 +2571,7 @@
           <a:p>
             <a:pPr lvl="0"/>
             <a:r>
-              <a:rPr lang="en-US" smtClean="0"/>
+              <a:rPr lang="en-US"/>
               <a:t>Click to edit Master text styles</a:t>
             </a:r>
           </a:p>
@@ -2553,7 +2594,7 @@
           <a:p>
             <a:fld id="{5BCAD085-E8A6-8845-BD4E-CB4CCA059FC4}" type="datetimeFigureOut">
               <a:rPr lang="en-US" smtClean="0"/>
-              <a:t>1/27/13</a:t>
+              <a:t>7/21/2026</a:t>
             </a:fld>
             <a:endParaRPr lang="en-US"/>
           </a:p>
@@ -2595,7 +2636,7 @@
           <a:p>
             <a:fld id="{C1FF6DA9-008F-8B48-92A6-B652298478BF}" type="slidenum">
               <a:rPr lang="en-US" smtClean="0"/>
-              <a:t>‹#›</a:t>
+              <a:t>‹Nº›</a:t>
             </a:fld>
             <a:endParaRPr lang="en-US"/>
           </a:p>
@@ -2662,10 +2703,9 @@
           <a:lstStyle/>
           <a:p>
             <a:r>
-              <a:rPr lang="en-US" smtClean="0"/>
+              <a:rPr lang="en-US"/>
               <a:t>Click to edit Master title style</a:t>
             </a:r>
-            <a:endParaRPr lang="en-US"/>
           </a:p>
         </p:txBody>
       </p:sp>
@@ -2696,38 +2736,37 @@
           <a:p>
             <a:pPr lvl="0"/>
             <a:r>
-              <a:rPr lang="en-US" smtClean="0"/>
+              <a:rPr lang="en-US"/>
               <a:t>Click to edit Master text styles</a:t>
             </a:r>
           </a:p>
           <a:p>
             <a:pPr lvl="1"/>
             <a:r>
-              <a:rPr lang="en-US" smtClean="0"/>
+              <a:rPr lang="en-US"/>
               <a:t>Second level</a:t>
             </a:r>
           </a:p>
           <a:p>
             <a:pPr lvl="2"/>
             <a:r>
-              <a:rPr lang="en-US" smtClean="0"/>
+              <a:rPr lang="en-US"/>
               <a:t>Third level</a:t>
             </a:r>
           </a:p>
           <a:p>
             <a:pPr lvl="3"/>
             <a:r>
-              <a:rPr lang="en-US" smtClean="0"/>
+              <a:rPr lang="en-US"/>
               <a:t>Fourth level</a:t>
             </a:r>
           </a:p>
           <a:p>
             <a:pPr lvl="4"/>
             <a:r>
-              <a:rPr lang="en-US" smtClean="0"/>
+              <a:rPr lang="en-US"/>
               <a:t>Fifth level</a:t>
             </a:r>
-            <a:endParaRPr lang="en-US"/>
           </a:p>
         </p:txBody>
       </p:sp>
@@ -2766,7 +2805,7 @@
           <a:p>
             <a:fld id="{5BCAD085-E8A6-8845-BD4E-CB4CCA059FC4}" type="datetimeFigureOut">
               <a:rPr lang="en-US" smtClean="0"/>
-              <a:t>1/27/13</a:t>
+              <a:t>7/21/2026</a:t>
             </a:fld>
             <a:endParaRPr lang="en-US"/>
           </a:p>
@@ -2844,9 +2883,57 @@
           <a:p>
             <a:fld id="{C1FF6DA9-008F-8B48-92A6-B652298478BF}" type="slidenum">
               <a:rPr lang="en-US" smtClean="0"/>
-              <a:t>‹#›</a:t>
+              <a:t>‹Nº›</a:t>
             </a:fld>
             <a:endParaRPr lang="en-US"/>
+          </a:p>
+        </p:txBody>
+      </p:sp>
+      <p:sp>
+        <p:nvSpPr>
+          <p:cNvPr id="8" name="CuadroTexto 7">
+            <a:extLst>
+              <a:ext uri="{FF2B5EF4-FFF2-40B4-BE49-F238E27FC236}">
+                <a16:creationId xmlns:a16="http://schemas.microsoft.com/office/drawing/2014/main" id="{A2C00982-A475-5FBC-BDDF-47383EED8AC7}"/>
+              </a:ext>
+            </a:extLst>
+          </p:cNvPr>
+          <p:cNvSpPr txBox="1"/>
+          <p:nvPr userDrawn="1">
+            <p:extLst>
+              <p:ext uri="{1162E1C5-73C7-4A58-AE30-91384D911F3F}">
+                <p184:classification xmlns:p184="http://schemas.microsoft.com/office/powerpoint/2018/4/main" val="ftr"/>
+              </p:ext>
+            </p:extLst>
+          </p:nvPr>
+        </p:nvSpPr>
+        <p:spPr>
+          <a:xfrm>
+            <a:off x="4543425" y="6642100"/>
+            <a:ext cx="3130550" cy="152400"/>
+          </a:xfrm>
+          <a:prstGeom prst="rect">
+            <a:avLst/>
+          </a:prstGeom>
+        </p:spPr>
+        <p:txBody>
+          <a:bodyPr horzOverflow="overflow" lIns="0" tIns="0" rIns="0" bIns="0">
+            <a:spAutoFit/>
+          </a:bodyPr>
+          <a:lstStyle/>
+          <a:p>
+            <a:pPr algn="l"/>
+            <a:r>
+              <a:rPr lang="es-AR" sz="1000">
+                <a:solidFill>
+                  <a:srgbClr val="000000">
+                    <a:alpha val="50000"/>
+                  </a:srgbClr>
+                </a:solidFill>
+                <a:latin typeface="Aptos" panose="020B0004020202020204" pitchFamily="34" charset="0"/>
+              </a:rPr>
+              <a:t>Confidential - Not for Public Consumption or Distribution</a:t>
+            </a:r>
           </a:p>
         </p:txBody>
       </p:sp>
@@ -3125,7 +3212,7 @@
 </file>
 
 <file path=ppt/slides/slide1.xml><?xml version="1.0" encoding="utf-8"?>
-<p:sld xmlns:a="http://schemas.openxmlformats.org/drawingml/2006/main" xmlns:p="http://schemas.openxmlformats.org/presentationml/2006/main" xmlns:r="http://schemas.openxmlformats.org/officeDocument/2006/relationships">
+<p:sld xmlns:a="http://schemas.openxmlformats.org/drawingml/2006/main" xmlns:r="http://schemas.openxmlformats.org/officeDocument/2006/relationships" xmlns:p="http://schemas.openxmlformats.org/presentationml/2006/main">
   <p:cSld>
     <p:spTree>
       <p:nvGrpSpPr>
@@ -3133,7 +3220,14 @@
         <p:cNvGrpSpPr/>
         <p:nvPr/>
       </p:nvGrpSpPr>
-      <p:grpSpPr/>
+      <p:grpSpPr>
+        <a:xfrm>
+          <a:off x="0" y="0"/>
+          <a:ext cx="0" cy="0"/>
+          <a:chOff x="0" y="0"/>
+          <a:chExt cx="0" cy="0"/>
+        </a:xfrm>
+      </p:grpSpPr>
       <p:sp>
         <p:nvSpPr>
           <p:cNvPr id="2" name="Rectangle 1"/>
@@ -3174,6 +3268,7 @@
           <a:lstStyle/>
           <a:p>
             <a:pPr algn="ctr"/>
+            <a:endParaRPr/>
           </a:p>
         </p:txBody>
       </p:sp>
@@ -3217,6 +3312,7 @@
           <a:lstStyle/>
           <a:p>
             <a:pPr algn="ctr"/>
+            <a:endParaRPr/>
           </a:p>
         </p:txBody>
       </p:sp>
@@ -3300,7 +3396,7 @@
 </file>
 
 <file path=ppt/slides/slide10.xml><?xml version="1.0" encoding="utf-8"?>
-<p:sld xmlns:a="http://schemas.openxmlformats.org/drawingml/2006/main" xmlns:p="http://schemas.openxmlformats.org/presentationml/2006/main" xmlns:r="http://schemas.openxmlformats.org/officeDocument/2006/relationships">
+<p:sld xmlns:a="http://schemas.openxmlformats.org/drawingml/2006/main" xmlns:r="http://schemas.openxmlformats.org/officeDocument/2006/relationships" xmlns:p="http://schemas.openxmlformats.org/presentationml/2006/main">
   <p:cSld>
     <p:spTree>
       <p:nvGrpSpPr>
@@ -3308,7 +3404,14 @@
         <p:cNvGrpSpPr/>
         <p:nvPr/>
       </p:nvGrpSpPr>
-      <p:grpSpPr/>
+      <p:grpSpPr>
+        <a:xfrm>
+          <a:off x="0" y="0"/>
+          <a:ext cx="0" cy="0"/>
+          <a:chOff x="0" y="0"/>
+          <a:chExt cx="0" cy="0"/>
+        </a:xfrm>
+      </p:grpSpPr>
       <p:sp>
         <p:nvSpPr>
           <p:cNvPr id="2" name="Rectangle 1"/>
@@ -3349,6 +3452,7 @@
           <a:lstStyle/>
           <a:p>
             <a:pPr algn="ctr"/>
+            <a:endParaRPr/>
           </a:p>
         </p:txBody>
       </p:sp>
@@ -3498,7 +3602,7 @@
               </a:spcAft>
             </a:pPr>
             <a:r>
-              <a:rPr b="1" sz="1200">
+              <a:rPr sz="1200" b="1">
                 <a:solidFill>
                   <a:srgbClr val="14213D"/>
                 </a:solidFill>
@@ -3588,7 +3692,7 @@
 </file>
 
 <file path=ppt/slides/slide11.xml><?xml version="1.0" encoding="utf-8"?>
-<p:sld xmlns:a="http://schemas.openxmlformats.org/drawingml/2006/main" xmlns:p="http://schemas.openxmlformats.org/presentationml/2006/main" xmlns:r="http://schemas.openxmlformats.org/officeDocument/2006/relationships">
+<p:sld xmlns:a="http://schemas.openxmlformats.org/drawingml/2006/main" xmlns:r="http://schemas.openxmlformats.org/officeDocument/2006/relationships" xmlns:p="http://schemas.openxmlformats.org/presentationml/2006/main">
   <p:cSld>
     <p:spTree>
       <p:nvGrpSpPr>
@@ -3596,7 +3700,14 @@
         <p:cNvGrpSpPr/>
         <p:nvPr/>
       </p:nvGrpSpPr>
-      <p:grpSpPr/>
+      <p:grpSpPr>
+        <a:xfrm>
+          <a:off x="0" y="0"/>
+          <a:ext cx="0" cy="0"/>
+          <a:chOff x="0" y="0"/>
+          <a:chExt cx="0" cy="0"/>
+        </a:xfrm>
+      </p:grpSpPr>
       <p:sp>
         <p:nvSpPr>
           <p:cNvPr id="2" name="Rectangle 1"/>
@@ -3637,6 +3748,7 @@
           <a:lstStyle/>
           <a:p>
             <a:pPr algn="ctr"/>
+            <a:endParaRPr/>
           </a:p>
         </p:txBody>
       </p:sp>
@@ -3738,7 +3850,7 @@
               </a:spcAft>
             </a:pPr>
             <a:r>
-              <a:rPr b="1" sz="1200">
+              <a:rPr sz="1200" b="1">
                 <a:solidFill>
                   <a:srgbClr val="14213D"/>
                 </a:solidFill>
@@ -3763,7 +3875,7 @@
               </a:spcAft>
             </a:pPr>
             <a:r>
-              <a:rPr b="1" sz="1200">
+              <a:rPr sz="1200" b="1">
                 <a:solidFill>
                   <a:srgbClr val="14213D"/>
                 </a:solidFill>
@@ -3804,7 +3916,7 @@
               </a:spcAft>
             </a:pPr>
             <a:r>
-              <a:rPr b="1" sz="1200">
+              <a:rPr sz="1200" b="1">
                 <a:solidFill>
                   <a:srgbClr val="14213D"/>
                 </a:solidFill>
@@ -3829,7 +3941,7 @@
               </a:spcAft>
             </a:pPr>
             <a:r>
-              <a:rPr b="1" sz="1200">
+              <a:rPr sz="1200" b="1">
                 <a:solidFill>
                   <a:srgbClr val="14213D"/>
                 </a:solidFill>
@@ -3854,7 +3966,7 @@
               </a:spcAft>
             </a:pPr>
             <a:r>
-              <a:rPr b="1" sz="1200">
+              <a:rPr sz="1200" b="1">
                 <a:solidFill>
                   <a:srgbClr val="14213D"/>
                 </a:solidFill>
@@ -3879,7 +3991,7 @@
               </a:spcAft>
             </a:pPr>
             <a:r>
-              <a:rPr b="1" sz="1200">
+              <a:rPr sz="1200" b="1">
                 <a:solidFill>
                   <a:srgbClr val="14213D"/>
                 </a:solidFill>
@@ -3953,7 +4065,7 @@
 </file>
 
 <file path=ppt/slides/slide12.xml><?xml version="1.0" encoding="utf-8"?>
-<p:sld xmlns:a="http://schemas.openxmlformats.org/drawingml/2006/main" xmlns:p="http://schemas.openxmlformats.org/presentationml/2006/main" xmlns:r="http://schemas.openxmlformats.org/officeDocument/2006/relationships">
+<p:sld xmlns:a="http://schemas.openxmlformats.org/drawingml/2006/main" xmlns:r="http://schemas.openxmlformats.org/officeDocument/2006/relationships" xmlns:p="http://schemas.openxmlformats.org/presentationml/2006/main">
   <p:cSld>
     <p:spTree>
       <p:nvGrpSpPr>
@@ -3961,7 +4073,14 @@
         <p:cNvGrpSpPr/>
         <p:nvPr/>
       </p:nvGrpSpPr>
-      <p:grpSpPr/>
+      <p:grpSpPr>
+        <a:xfrm>
+          <a:off x="0" y="0"/>
+          <a:ext cx="0" cy="0"/>
+          <a:chOff x="0" y="0"/>
+          <a:chExt cx="0" cy="0"/>
+        </a:xfrm>
+      </p:grpSpPr>
       <p:sp>
         <p:nvSpPr>
           <p:cNvPr id="2" name="Rectangle 1"/>
@@ -4002,6 +4121,7 @@
           <a:lstStyle/>
           <a:p>
             <a:pPr algn="ctr"/>
+            <a:endParaRPr/>
           </a:p>
         </p:txBody>
       </p:sp>
@@ -4103,7 +4223,7 @@
               </a:spcAft>
             </a:pPr>
             <a:r>
-              <a:rPr b="1" sz="1400">
+              <a:rPr sz="1400" b="1">
                 <a:solidFill>
                   <a:srgbClr val="14213D"/>
                 </a:solidFill>
@@ -4128,7 +4248,7 @@
               </a:spcAft>
             </a:pPr>
             <a:r>
-              <a:rPr b="1" sz="1400">
+              <a:rPr sz="1400" b="1">
                 <a:solidFill>
                   <a:srgbClr val="14213D"/>
                 </a:solidFill>
@@ -4153,7 +4273,7 @@
               </a:spcAft>
             </a:pPr>
             <a:r>
-              <a:rPr b="1" sz="1400">
+              <a:rPr sz="1400" b="1">
                 <a:solidFill>
                   <a:srgbClr val="14213D"/>
                 </a:solidFill>
@@ -4178,7 +4298,7 @@
               </a:spcAft>
             </a:pPr>
             <a:r>
-              <a:rPr b="1" sz="1400">
+              <a:rPr sz="1400" b="1">
                 <a:solidFill>
                   <a:srgbClr val="14213D"/>
                 </a:solidFill>
@@ -4203,7 +4323,7 @@
               </a:spcAft>
             </a:pPr>
             <a:r>
-              <a:rPr b="1" sz="1400">
+              <a:rPr sz="1400" b="1">
                 <a:solidFill>
                   <a:srgbClr val="14213D"/>
                 </a:solidFill>
@@ -4228,7 +4348,7 @@
               </a:spcAft>
             </a:pPr>
             <a:r>
-              <a:rPr b="1" sz="1400">
+              <a:rPr sz="1400" b="1">
                 <a:solidFill>
                   <a:srgbClr val="14213D"/>
                 </a:solidFill>
@@ -4257,7 +4377,7 @@
 </file>
 
 <file path=ppt/slides/slide13.xml><?xml version="1.0" encoding="utf-8"?>
-<p:sld xmlns:a="http://schemas.openxmlformats.org/drawingml/2006/main" xmlns:p="http://schemas.openxmlformats.org/presentationml/2006/main" xmlns:r="http://schemas.openxmlformats.org/officeDocument/2006/relationships">
+<p:sld xmlns:a="http://schemas.openxmlformats.org/drawingml/2006/main" xmlns:r="http://schemas.openxmlformats.org/officeDocument/2006/relationships" xmlns:p="http://schemas.openxmlformats.org/presentationml/2006/main">
   <p:cSld>
     <p:spTree>
       <p:nvGrpSpPr>
@@ -4265,7 +4385,14 @@
         <p:cNvGrpSpPr/>
         <p:nvPr/>
       </p:nvGrpSpPr>
-      <p:grpSpPr/>
+      <p:grpSpPr>
+        <a:xfrm>
+          <a:off x="0" y="0"/>
+          <a:ext cx="0" cy="0"/>
+          <a:chOff x="0" y="0"/>
+          <a:chExt cx="0" cy="0"/>
+        </a:xfrm>
+      </p:grpSpPr>
       <p:sp>
         <p:nvSpPr>
           <p:cNvPr id="2" name="Rectangle 1"/>
@@ -4306,6 +4433,7 @@
           <a:lstStyle/>
           <a:p>
             <a:pPr algn="ctr"/>
+            <a:endParaRPr/>
           </a:p>
         </p:txBody>
       </p:sp>
@@ -4404,7 +4532,7 @@
               </a:spcAft>
             </a:pPr>
             <a:r>
-              <a:rPr b="1" sz="1200">
+              <a:rPr sz="1200" b="1">
                 <a:solidFill>
                   <a:srgbClr val="14213D"/>
                 </a:solidFill>
@@ -4429,7 +4557,7 @@
               </a:spcAft>
             </a:pPr>
             <a:r>
-              <a:rPr b="1" sz="1200">
+              <a:rPr sz="1200" b="1">
                 <a:solidFill>
                   <a:srgbClr val="14213D"/>
                 </a:solidFill>
@@ -4454,7 +4582,7 @@
               </a:spcAft>
             </a:pPr>
             <a:r>
-              <a:rPr b="1" sz="1200">
+              <a:rPr sz="1200" b="1">
                 <a:solidFill>
                   <a:srgbClr val="14213D"/>
                 </a:solidFill>
@@ -4479,7 +4607,7 @@
               </a:spcAft>
             </a:pPr>
             <a:r>
-              <a:rPr b="1" sz="1200">
+              <a:rPr sz="1200" b="1">
                 <a:solidFill>
                   <a:srgbClr val="14213D"/>
                 </a:solidFill>
@@ -4537,7 +4665,7 @@
 </file>
 
 <file path=ppt/slides/slide14.xml><?xml version="1.0" encoding="utf-8"?>
-<p:sld xmlns:a="http://schemas.openxmlformats.org/drawingml/2006/main" xmlns:p="http://schemas.openxmlformats.org/presentationml/2006/main" xmlns:r="http://schemas.openxmlformats.org/officeDocument/2006/relationships">
+<p:sld xmlns:a="http://schemas.openxmlformats.org/drawingml/2006/main" xmlns:r="http://schemas.openxmlformats.org/officeDocument/2006/relationships" xmlns:p="http://schemas.openxmlformats.org/presentationml/2006/main">
   <p:cSld>
     <p:spTree>
       <p:nvGrpSpPr>
@@ -4545,7 +4673,14 @@
         <p:cNvGrpSpPr/>
         <p:nvPr/>
       </p:nvGrpSpPr>
-      <p:grpSpPr/>
+      <p:grpSpPr>
+        <a:xfrm>
+          <a:off x="0" y="0"/>
+          <a:ext cx="0" cy="0"/>
+          <a:chOff x="0" y="0"/>
+          <a:chExt cx="0" cy="0"/>
+        </a:xfrm>
+      </p:grpSpPr>
       <p:sp>
         <p:nvSpPr>
           <p:cNvPr id="2" name="Rectangle 1"/>
@@ -4586,6 +4721,7 @@
           <a:lstStyle/>
           <a:p>
             <a:pPr algn="ctr"/>
+            <a:endParaRPr/>
           </a:p>
         </p:txBody>
       </p:sp>
@@ -4652,7 +4788,7 @@
               </a:spcAft>
             </a:pPr>
             <a:r>
-              <a:rPr b="1" sz="1200">
+              <a:rPr sz="1200" b="1">
                 <a:solidFill>
                   <a:srgbClr val="14213D"/>
                 </a:solidFill>
@@ -4677,7 +4813,7 @@
               </a:spcAft>
             </a:pPr>
             <a:r>
-              <a:rPr b="1" sz="1200">
+              <a:rPr sz="1200" b="1">
                 <a:solidFill>
                   <a:srgbClr val="14213D"/>
                 </a:solidFill>
@@ -4734,7 +4870,7 @@
               </a:spcAft>
             </a:pPr>
             <a:r>
-              <a:rPr b="1" sz="1200">
+              <a:rPr sz="1200" b="1">
                 <a:solidFill>
                   <a:srgbClr val="14213D"/>
                 </a:solidFill>
@@ -4792,7 +4928,7 @@
 </file>
 
 <file path=ppt/slides/slide15.xml><?xml version="1.0" encoding="utf-8"?>
-<p:sld xmlns:a="http://schemas.openxmlformats.org/drawingml/2006/main" xmlns:p="http://schemas.openxmlformats.org/presentationml/2006/main" xmlns:r="http://schemas.openxmlformats.org/officeDocument/2006/relationships">
+<p:sld xmlns:a="http://schemas.openxmlformats.org/drawingml/2006/main" xmlns:r="http://schemas.openxmlformats.org/officeDocument/2006/relationships" xmlns:p="http://schemas.openxmlformats.org/presentationml/2006/main">
   <p:cSld>
     <p:spTree>
       <p:nvGrpSpPr>
@@ -4800,7 +4936,14 @@
         <p:cNvGrpSpPr/>
         <p:nvPr/>
       </p:nvGrpSpPr>
-      <p:grpSpPr/>
+      <p:grpSpPr>
+        <a:xfrm>
+          <a:off x="0" y="0"/>
+          <a:ext cx="0" cy="0"/>
+          <a:chOff x="0" y="0"/>
+          <a:chExt cx="0" cy="0"/>
+        </a:xfrm>
+      </p:grpSpPr>
       <p:sp>
         <p:nvSpPr>
           <p:cNvPr id="2" name="Rectangle 1"/>
@@ -4841,6 +4984,7 @@
           <a:lstStyle/>
           <a:p>
             <a:pPr algn="ctr"/>
+            <a:endParaRPr/>
           </a:p>
         </p:txBody>
       </p:sp>
@@ -4923,7 +5067,7 @@
               </a:spcAft>
             </a:pPr>
             <a:r>
-              <a:rPr b="1" sz="1200">
+              <a:rPr sz="1200" b="1">
                 <a:solidFill>
                   <a:srgbClr val="14213D"/>
                 </a:solidFill>
@@ -4948,7 +5092,7 @@
               </a:spcAft>
             </a:pPr>
             <a:r>
-              <a:rPr b="1" sz="1200">
+              <a:rPr sz="1200" b="1">
                 <a:solidFill>
                   <a:srgbClr val="14213D"/>
                 </a:solidFill>
@@ -4973,7 +5117,7 @@
               </a:spcAft>
             </a:pPr>
             <a:r>
-              <a:rPr b="1" sz="1200">
+              <a:rPr sz="1200" b="1">
                 <a:solidFill>
                   <a:srgbClr val="14213D"/>
                 </a:solidFill>
@@ -4998,7 +5142,7 @@
               </a:spcAft>
             </a:pPr>
             <a:r>
-              <a:rPr b="1" sz="1200">
+              <a:rPr sz="1200" b="1">
                 <a:solidFill>
                   <a:srgbClr val="14213D"/>
                 </a:solidFill>
@@ -5023,7 +5167,7 @@
               </a:spcAft>
             </a:pPr>
             <a:r>
-              <a:rPr b="1" sz="1200">
+              <a:rPr sz="1200" b="1">
                 <a:solidFill>
                   <a:srgbClr val="14213D"/>
                 </a:solidFill>
@@ -5097,7 +5241,7 @@
 </file>
 
 <file path=ppt/slides/slide16.xml><?xml version="1.0" encoding="utf-8"?>
-<p:sld xmlns:a="http://schemas.openxmlformats.org/drawingml/2006/main" xmlns:p="http://schemas.openxmlformats.org/presentationml/2006/main" xmlns:r="http://schemas.openxmlformats.org/officeDocument/2006/relationships">
+<p:sld xmlns:a="http://schemas.openxmlformats.org/drawingml/2006/main" xmlns:r="http://schemas.openxmlformats.org/officeDocument/2006/relationships" xmlns:p="http://schemas.openxmlformats.org/presentationml/2006/main">
   <p:cSld>
     <p:spTree>
       <p:nvGrpSpPr>
@@ -5105,7 +5249,14 @@
         <p:cNvGrpSpPr/>
         <p:nvPr/>
       </p:nvGrpSpPr>
-      <p:grpSpPr/>
+      <p:grpSpPr>
+        <a:xfrm>
+          <a:off x="0" y="0"/>
+          <a:ext cx="0" cy="0"/>
+          <a:chOff x="0" y="0"/>
+          <a:chExt cx="0" cy="0"/>
+        </a:xfrm>
+      </p:grpSpPr>
       <p:sp>
         <p:nvSpPr>
           <p:cNvPr id="2" name="Rectangle 1"/>
@@ -5146,6 +5297,7 @@
           <a:lstStyle/>
           <a:p>
             <a:pPr algn="ctr"/>
+            <a:endParaRPr/>
           </a:p>
         </p:txBody>
       </p:sp>
@@ -5228,7 +5380,7 @@
               </a:spcAft>
             </a:pPr>
             <a:r>
-              <a:rPr b="1" sz="1200">
+              <a:rPr sz="1200" b="1">
                 <a:solidFill>
                   <a:srgbClr val="14213D"/>
                 </a:solidFill>
@@ -5285,7 +5437,7 @@
               </a:spcAft>
             </a:pPr>
             <a:r>
-              <a:rPr b="1" sz="1100">
+              <a:rPr sz="1100" b="1">
                 <a:solidFill>
                   <a:srgbClr val="14213D"/>
                 </a:solidFill>
@@ -5310,7 +5462,7 @@
               </a:spcAft>
             </a:pPr>
             <a:r>
-              <a:rPr b="1" sz="1100">
+              <a:rPr sz="1100" b="1">
                 <a:solidFill>
                   <a:srgbClr val="14213D"/>
                 </a:solidFill>
@@ -5335,7 +5487,7 @@
               </a:spcAft>
             </a:pPr>
             <a:r>
-              <a:rPr b="1" sz="1200">
+              <a:rPr sz="1200" b="1">
                 <a:solidFill>
                   <a:srgbClr val="14213D"/>
                 </a:solidFill>
@@ -5393,7 +5545,7 @@
 </file>
 
 <file path=ppt/slides/slide17.xml><?xml version="1.0" encoding="utf-8"?>
-<p:sld xmlns:a="http://schemas.openxmlformats.org/drawingml/2006/main" xmlns:p="http://schemas.openxmlformats.org/presentationml/2006/main" xmlns:r="http://schemas.openxmlformats.org/officeDocument/2006/relationships">
+<p:sld xmlns:a="http://schemas.openxmlformats.org/drawingml/2006/main" xmlns:r="http://schemas.openxmlformats.org/officeDocument/2006/relationships" xmlns:p="http://schemas.openxmlformats.org/presentationml/2006/main">
   <p:cSld>
     <p:spTree>
       <p:nvGrpSpPr>
@@ -5401,7 +5553,14 @@
         <p:cNvGrpSpPr/>
         <p:nvPr/>
       </p:nvGrpSpPr>
-      <p:grpSpPr/>
+      <p:grpSpPr>
+        <a:xfrm>
+          <a:off x="0" y="0"/>
+          <a:ext cx="0" cy="0"/>
+          <a:chOff x="0" y="0"/>
+          <a:chExt cx="0" cy="0"/>
+        </a:xfrm>
+      </p:grpSpPr>
       <p:sp>
         <p:nvSpPr>
           <p:cNvPr id="2" name="Rectangle 1"/>
@@ -5442,6 +5601,7 @@
           <a:lstStyle/>
           <a:p>
             <a:pPr algn="ctr"/>
+            <a:endParaRPr/>
           </a:p>
         </p:txBody>
       </p:sp>
@@ -5572,7 +5732,7 @@
               </a:spcAft>
             </a:pPr>
             <a:r>
-              <a:rPr b="1" sz="1300">
+              <a:rPr sz="1300" b="1">
                 <a:solidFill>
                   <a:srgbClr val="14213D"/>
                 </a:solidFill>
@@ -5597,7 +5757,7 @@
               </a:spcAft>
             </a:pPr>
             <a:r>
-              <a:rPr b="1" sz="1300">
+              <a:rPr sz="1300" b="1">
                 <a:solidFill>
                   <a:srgbClr val="14213D"/>
                 </a:solidFill>
@@ -5645,7 +5805,7 @@
               </a:spcAft>
             </a:pPr>
             <a:r>
-              <a:rPr b="1" sz="1300">
+              <a:rPr sz="1300" b="1">
                 <a:solidFill>
                   <a:srgbClr val="14213D"/>
                 </a:solidFill>
@@ -5686,7 +5846,7 @@
               </a:spcAft>
             </a:pPr>
             <a:r>
-              <a:rPr b="1" sz="1300">
+              <a:rPr sz="1300" b="1">
                 <a:solidFill>
                   <a:srgbClr val="14213D"/>
                 </a:solidFill>
@@ -5711,7 +5871,7 @@
               </a:spcAft>
             </a:pPr>
             <a:r>
-              <a:rPr b="1" sz="1300">
+              <a:rPr sz="1300" b="1">
                 <a:solidFill>
                   <a:srgbClr val="14213D"/>
                 </a:solidFill>
@@ -5756,7 +5916,7 @@
 </file>
 
 <file path=ppt/slides/slide18.xml><?xml version="1.0" encoding="utf-8"?>
-<p:sld xmlns:a="http://schemas.openxmlformats.org/drawingml/2006/main" xmlns:p="http://schemas.openxmlformats.org/presentationml/2006/main" xmlns:r="http://schemas.openxmlformats.org/officeDocument/2006/relationships">
+<p:sld xmlns:a="http://schemas.openxmlformats.org/drawingml/2006/main" xmlns:r="http://schemas.openxmlformats.org/officeDocument/2006/relationships" xmlns:p="http://schemas.openxmlformats.org/presentationml/2006/main">
   <p:cSld>
     <p:spTree>
       <p:nvGrpSpPr>
@@ -5764,7 +5924,14 @@
         <p:cNvGrpSpPr/>
         <p:nvPr/>
       </p:nvGrpSpPr>
-      <p:grpSpPr/>
+      <p:grpSpPr>
+        <a:xfrm>
+          <a:off x="0" y="0"/>
+          <a:ext cx="0" cy="0"/>
+          <a:chOff x="0" y="0"/>
+          <a:chExt cx="0" cy="0"/>
+        </a:xfrm>
+      </p:grpSpPr>
       <p:sp>
         <p:nvSpPr>
           <p:cNvPr id="2" name="Rectangle 1"/>
@@ -5805,6 +5972,7 @@
           <a:lstStyle/>
           <a:p>
             <a:pPr algn="ctr"/>
+            <a:endParaRPr/>
           </a:p>
         </p:txBody>
       </p:sp>
@@ -5887,7 +6055,7 @@
               </a:spcAft>
             </a:pPr>
             <a:r>
-              <a:rPr b="1" sz="1400">
+              <a:rPr sz="1400" b="1">
                 <a:solidFill>
                   <a:srgbClr val="14213D"/>
                 </a:solidFill>
@@ -5912,7 +6080,7 @@
               </a:spcAft>
             </a:pPr>
             <a:r>
-              <a:rPr b="1" sz="1400">
+              <a:rPr sz="1400" b="1">
                 <a:solidFill>
                   <a:srgbClr val="14213D"/>
                 </a:solidFill>
@@ -5937,7 +6105,7 @@
               </a:spcAft>
             </a:pPr>
             <a:r>
-              <a:rPr b="1" sz="1400">
+              <a:rPr sz="1400" b="1">
                 <a:solidFill>
                   <a:srgbClr val="14213D"/>
                 </a:solidFill>
@@ -6014,7 +6182,7 @@
 </file>
 
 <file path=ppt/slides/slide19.xml><?xml version="1.0" encoding="utf-8"?>
-<p:sld xmlns:a="http://schemas.openxmlformats.org/drawingml/2006/main" xmlns:p="http://schemas.openxmlformats.org/presentationml/2006/main" xmlns:r="http://schemas.openxmlformats.org/officeDocument/2006/relationships">
+<p:sld xmlns:a="http://schemas.openxmlformats.org/drawingml/2006/main" xmlns:r="http://schemas.openxmlformats.org/officeDocument/2006/relationships" xmlns:p="http://schemas.openxmlformats.org/presentationml/2006/main">
   <p:cSld>
     <p:spTree>
       <p:nvGrpSpPr>
@@ -6022,7 +6190,14 @@
         <p:cNvGrpSpPr/>
         <p:nvPr/>
       </p:nvGrpSpPr>
-      <p:grpSpPr/>
+      <p:grpSpPr>
+        <a:xfrm>
+          <a:off x="0" y="0"/>
+          <a:ext cx="0" cy="0"/>
+          <a:chOff x="0" y="0"/>
+          <a:chExt cx="0" cy="0"/>
+        </a:xfrm>
+      </p:grpSpPr>
       <p:sp>
         <p:nvSpPr>
           <p:cNvPr id="2" name="Rectangle 1"/>
@@ -6063,6 +6238,7 @@
           <a:lstStyle/>
           <a:p>
             <a:pPr algn="ctr"/>
+            <a:endParaRPr/>
           </a:p>
         </p:txBody>
       </p:sp>
@@ -6145,7 +6321,7 @@
               </a:spcAft>
             </a:pPr>
             <a:r>
-              <a:rPr b="1" sz="1200">
+              <a:rPr sz="1200" b="1">
                 <a:solidFill>
                   <a:srgbClr val="14213D"/>
                 </a:solidFill>
@@ -6170,7 +6346,7 @@
               </a:spcAft>
             </a:pPr>
             <a:r>
-              <a:rPr b="1" sz="1200">
+              <a:rPr sz="1200" b="1">
                 <a:solidFill>
                   <a:srgbClr val="14213D"/>
                 </a:solidFill>
@@ -6195,7 +6371,7 @@
               </a:spcAft>
             </a:pPr>
             <a:r>
-              <a:rPr b="1" sz="1200">
+              <a:rPr sz="1200" b="1">
                 <a:solidFill>
                   <a:srgbClr val="14213D"/>
                 </a:solidFill>
@@ -6220,7 +6396,7 @@
               </a:spcAft>
             </a:pPr>
             <a:r>
-              <a:rPr b="1" sz="1200">
+              <a:rPr sz="1200" b="1">
                 <a:solidFill>
                   <a:srgbClr val="14213D"/>
                 </a:solidFill>
@@ -6278,7 +6454,7 @@
 </file>
 
 <file path=ppt/slides/slide2.xml><?xml version="1.0" encoding="utf-8"?>
-<p:sld xmlns:a="http://schemas.openxmlformats.org/drawingml/2006/main" xmlns:p="http://schemas.openxmlformats.org/presentationml/2006/main" xmlns:r="http://schemas.openxmlformats.org/officeDocument/2006/relationships">
+<p:sld xmlns:a="http://schemas.openxmlformats.org/drawingml/2006/main" xmlns:r="http://schemas.openxmlformats.org/officeDocument/2006/relationships" xmlns:p="http://schemas.openxmlformats.org/presentationml/2006/main">
   <p:cSld>
     <p:spTree>
       <p:nvGrpSpPr>
@@ -6286,7 +6462,14 @@
         <p:cNvGrpSpPr/>
         <p:nvPr/>
       </p:nvGrpSpPr>
-      <p:grpSpPr/>
+      <p:grpSpPr>
+        <a:xfrm>
+          <a:off x="0" y="0"/>
+          <a:ext cx="0" cy="0"/>
+          <a:chOff x="0" y="0"/>
+          <a:chExt cx="0" cy="0"/>
+        </a:xfrm>
+      </p:grpSpPr>
       <p:sp>
         <p:nvSpPr>
           <p:cNvPr id="2" name="Rectangle 1"/>
@@ -6327,6 +6510,7 @@
           <a:lstStyle/>
           <a:p>
             <a:pPr algn="ctr"/>
+            <a:endParaRPr/>
           </a:p>
         </p:txBody>
       </p:sp>
@@ -6444,7 +6628,7 @@
               </a:spcAft>
             </a:pPr>
             <a:r>
-              <a:rPr b="1" sz="1400">
+              <a:rPr sz="1400" b="1">
                 <a:solidFill>
                   <a:srgbClr val="14213D"/>
                 </a:solidFill>
@@ -6485,7 +6669,7 @@
               </a:spcAft>
             </a:pPr>
             <a:r>
-              <a:rPr b="1" sz="1400">
+              <a:rPr sz="1400" b="1">
                 <a:solidFill>
                   <a:srgbClr val="14213D"/>
                 </a:solidFill>
@@ -6510,7 +6694,7 @@
               </a:spcAft>
             </a:pPr>
             <a:r>
-              <a:rPr b="1" sz="1400">
+              <a:rPr sz="1400" b="1">
                 <a:solidFill>
                   <a:srgbClr val="14213D"/>
                 </a:solidFill>
@@ -6551,7 +6735,7 @@
               </a:spcAft>
             </a:pPr>
             <a:r>
-              <a:rPr b="1" sz="1400">
+              <a:rPr sz="1400" b="1">
                 <a:solidFill>
                   <a:srgbClr val="14213D"/>
                 </a:solidFill>
@@ -6580,7 +6764,7 @@
 </file>
 
 <file path=ppt/slides/slide20.xml><?xml version="1.0" encoding="utf-8"?>
-<p:sld xmlns:a="http://schemas.openxmlformats.org/drawingml/2006/main" xmlns:p="http://schemas.openxmlformats.org/presentationml/2006/main" xmlns:r="http://schemas.openxmlformats.org/officeDocument/2006/relationships">
+<p:sld xmlns:a="http://schemas.openxmlformats.org/drawingml/2006/main" xmlns:r="http://schemas.openxmlformats.org/officeDocument/2006/relationships" xmlns:p="http://schemas.openxmlformats.org/presentationml/2006/main">
   <p:cSld>
     <p:spTree>
       <p:nvGrpSpPr>
@@ -6588,7 +6772,14 @@
         <p:cNvGrpSpPr/>
         <p:nvPr/>
       </p:nvGrpSpPr>
-      <p:grpSpPr/>
+      <p:grpSpPr>
+        <a:xfrm>
+          <a:off x="0" y="0"/>
+          <a:ext cx="0" cy="0"/>
+          <a:chOff x="0" y="0"/>
+          <a:chExt cx="0" cy="0"/>
+        </a:xfrm>
+      </p:grpSpPr>
       <p:sp>
         <p:nvSpPr>
           <p:cNvPr id="2" name="Rectangle 1"/>
@@ -6629,6 +6820,7 @@
           <a:lstStyle/>
           <a:p>
             <a:pPr algn="ctr"/>
+            <a:endParaRPr/>
           </a:p>
         </p:txBody>
       </p:sp>
@@ -6711,7 +6903,7 @@
               </a:spcAft>
             </a:pPr>
             <a:r>
-              <a:rPr b="1" sz="1200">
+              <a:rPr sz="1200" b="1">
                 <a:solidFill>
                   <a:srgbClr val="14213D"/>
                 </a:solidFill>
@@ -6784,7 +6976,7 @@
               </a:spcAft>
             </a:pPr>
             <a:r>
-              <a:rPr b="1" sz="1100">
+              <a:rPr sz="1100" b="1">
                 <a:solidFill>
                   <a:srgbClr val="14213D"/>
                 </a:solidFill>
@@ -6809,7 +7001,7 @@
               </a:spcAft>
             </a:pPr>
             <a:r>
-              <a:rPr b="1" sz="1100">
+              <a:rPr sz="1100" b="1">
                 <a:solidFill>
                   <a:srgbClr val="14213D"/>
                 </a:solidFill>
@@ -6834,7 +7026,7 @@
               </a:spcAft>
             </a:pPr>
             <a:r>
-              <a:rPr b="1" sz="1100">
+              <a:rPr sz="1100" b="1">
                 <a:solidFill>
                   <a:srgbClr val="14213D"/>
                 </a:solidFill>
@@ -6892,7 +7084,7 @@
 </file>
 
 <file path=ppt/slides/slide21.xml><?xml version="1.0" encoding="utf-8"?>
-<p:sld xmlns:a="http://schemas.openxmlformats.org/drawingml/2006/main" xmlns:p="http://schemas.openxmlformats.org/presentationml/2006/main" xmlns:r="http://schemas.openxmlformats.org/officeDocument/2006/relationships">
+<p:sld xmlns:a="http://schemas.openxmlformats.org/drawingml/2006/main" xmlns:r="http://schemas.openxmlformats.org/officeDocument/2006/relationships" xmlns:p="http://schemas.openxmlformats.org/presentationml/2006/main">
   <p:cSld>
     <p:spTree>
       <p:nvGrpSpPr>
@@ -6900,7 +7092,14 @@
         <p:cNvGrpSpPr/>
         <p:nvPr/>
       </p:nvGrpSpPr>
-      <p:grpSpPr/>
+      <p:grpSpPr>
+        <a:xfrm>
+          <a:off x="0" y="0"/>
+          <a:ext cx="0" cy="0"/>
+          <a:chOff x="0" y="0"/>
+          <a:chExt cx="0" cy="0"/>
+        </a:xfrm>
+      </p:grpSpPr>
       <p:sp>
         <p:nvSpPr>
           <p:cNvPr id="2" name="Rectangle 1"/>
@@ -6941,6 +7140,7 @@
           <a:lstStyle/>
           <a:p>
             <a:pPr algn="ctr"/>
+            <a:endParaRPr/>
           </a:p>
         </p:txBody>
       </p:sp>
@@ -7023,7 +7223,7 @@
               </a:spcAft>
             </a:pPr>
             <a:r>
-              <a:rPr b="1" sz="1150">
+              <a:rPr sz="1150" b="1">
                 <a:solidFill>
                   <a:srgbClr val="14213D"/>
                 </a:solidFill>
@@ -7048,7 +7248,7 @@
               </a:spcAft>
             </a:pPr>
             <a:r>
-              <a:rPr b="1" sz="1150">
+              <a:rPr sz="1150" b="1">
                 <a:solidFill>
                   <a:srgbClr val="14213D"/>
                 </a:solidFill>
@@ -7073,7 +7273,7 @@
               </a:spcAft>
             </a:pPr>
             <a:r>
-              <a:rPr b="1" sz="1150">
+              <a:rPr sz="1150" b="1">
                 <a:solidFill>
                   <a:srgbClr val="14213D"/>
                 </a:solidFill>
@@ -7098,7 +7298,7 @@
               </a:spcAft>
             </a:pPr>
             <a:r>
-              <a:rPr b="1" sz="1150">
+              <a:rPr sz="1150" b="1">
                 <a:solidFill>
                   <a:srgbClr val="14213D"/>
                 </a:solidFill>
@@ -7123,7 +7323,7 @@
               </a:spcAft>
             </a:pPr>
             <a:r>
-              <a:rPr b="1" sz="1150">
+              <a:rPr sz="1150" b="1">
                 <a:solidFill>
                   <a:srgbClr val="14213D"/>
                 </a:solidFill>
@@ -7203,7 +7403,7 @@
               </a:spcAft>
             </a:pPr>
             <a:r>
-              <a:rPr b="1" sz="1150">
+              <a:rPr sz="1150" b="1">
                 <a:solidFill>
                   <a:srgbClr val="14213D"/>
                 </a:solidFill>
@@ -7228,7 +7428,7 @@
               </a:spcAft>
             </a:pPr>
             <a:r>
-              <a:rPr b="1" sz="1150">
+              <a:rPr sz="1150" b="1">
                 <a:solidFill>
                   <a:srgbClr val="14213D"/>
                 </a:solidFill>
@@ -7273,7 +7473,7 @@
 </file>
 
 <file path=ppt/slides/slide22.xml><?xml version="1.0" encoding="utf-8"?>
-<p:sld xmlns:a="http://schemas.openxmlformats.org/drawingml/2006/main" xmlns:p="http://schemas.openxmlformats.org/presentationml/2006/main" xmlns:r="http://schemas.openxmlformats.org/officeDocument/2006/relationships">
+<p:sld xmlns:a="http://schemas.openxmlformats.org/drawingml/2006/main" xmlns:r="http://schemas.openxmlformats.org/officeDocument/2006/relationships" xmlns:p="http://schemas.openxmlformats.org/presentationml/2006/main">
   <p:cSld>
     <p:spTree>
       <p:nvGrpSpPr>
@@ -7281,7 +7481,14 @@
         <p:cNvGrpSpPr/>
         <p:nvPr/>
       </p:nvGrpSpPr>
-      <p:grpSpPr/>
+      <p:grpSpPr>
+        <a:xfrm>
+          <a:off x="0" y="0"/>
+          <a:ext cx="0" cy="0"/>
+          <a:chOff x="0" y="0"/>
+          <a:chExt cx="0" cy="0"/>
+        </a:xfrm>
+      </p:grpSpPr>
       <p:sp>
         <p:nvSpPr>
           <p:cNvPr id="2" name="Rectangle 1"/>
@@ -7322,6 +7529,7 @@
           <a:lstStyle/>
           <a:p>
             <a:pPr algn="ctr"/>
+            <a:endParaRPr/>
           </a:p>
         </p:txBody>
       </p:sp>
@@ -7365,6 +7573,7 @@
           <a:lstStyle/>
           <a:p>
             <a:pPr algn="ctr"/>
+            <a:endParaRPr/>
           </a:p>
         </p:txBody>
       </p:sp>
@@ -7482,7 +7691,7 @@
 </file>
 
 <file path=ppt/slides/slide23.xml><?xml version="1.0" encoding="utf-8"?>
-<p:sld xmlns:a="http://schemas.openxmlformats.org/drawingml/2006/main" xmlns:p="http://schemas.openxmlformats.org/presentationml/2006/main" xmlns:r="http://schemas.openxmlformats.org/officeDocument/2006/relationships">
+<p:sld xmlns:a="http://schemas.openxmlformats.org/drawingml/2006/main" xmlns:r="http://schemas.openxmlformats.org/officeDocument/2006/relationships" xmlns:p="http://schemas.openxmlformats.org/presentationml/2006/main">
   <p:cSld>
     <p:spTree>
       <p:nvGrpSpPr>
@@ -7490,7 +7699,14 @@
         <p:cNvGrpSpPr/>
         <p:nvPr/>
       </p:nvGrpSpPr>
-      <p:grpSpPr/>
+      <p:grpSpPr>
+        <a:xfrm>
+          <a:off x="0" y="0"/>
+          <a:ext cx="0" cy="0"/>
+          <a:chOff x="0" y="0"/>
+          <a:chExt cx="0" cy="0"/>
+        </a:xfrm>
+      </p:grpSpPr>
       <p:sp>
         <p:nvSpPr>
           <p:cNvPr id="2" name="Rectangle 1"/>
@@ -7531,6 +7747,7 @@
           <a:lstStyle/>
           <a:p>
             <a:pPr algn="ctr"/>
+            <a:endParaRPr/>
           </a:p>
         </p:txBody>
       </p:sp>
@@ -7613,7 +7830,7 @@
               </a:spcAft>
             </a:pPr>
             <a:r>
-              <a:rPr b="1" sz="1200">
+              <a:rPr sz="1200" b="1">
                 <a:solidFill>
                   <a:srgbClr val="14213D"/>
                 </a:solidFill>
@@ -7638,7 +7855,7 @@
               </a:spcAft>
             </a:pPr>
             <a:r>
-              <a:rPr b="1" sz="1200">
+              <a:rPr sz="1200" b="1">
                 <a:solidFill>
                   <a:srgbClr val="14213D"/>
                 </a:solidFill>
@@ -7679,7 +7896,7 @@
               </a:spcAft>
             </a:pPr>
             <a:r>
-              <a:rPr b="1" sz="1200">
+              <a:rPr sz="1200" b="1">
                 <a:solidFill>
                   <a:srgbClr val="14213D"/>
                 </a:solidFill>
@@ -7704,7 +7921,7 @@
               </a:spcAft>
             </a:pPr>
             <a:r>
-              <a:rPr b="1" sz="1200">
+              <a:rPr sz="1200" b="1">
                 <a:solidFill>
                   <a:srgbClr val="14213D"/>
                 </a:solidFill>
@@ -7762,7 +7979,7 @@
 </file>
 
 <file path=ppt/slides/slide24.xml><?xml version="1.0" encoding="utf-8"?>
-<p:sld xmlns:a="http://schemas.openxmlformats.org/drawingml/2006/main" xmlns:p="http://schemas.openxmlformats.org/presentationml/2006/main" xmlns:r="http://schemas.openxmlformats.org/officeDocument/2006/relationships">
+<p:sld xmlns:a="http://schemas.openxmlformats.org/drawingml/2006/main" xmlns:r="http://schemas.openxmlformats.org/officeDocument/2006/relationships" xmlns:p="http://schemas.openxmlformats.org/presentationml/2006/main">
   <p:cSld>
     <p:spTree>
       <p:nvGrpSpPr>
@@ -7770,7 +7987,14 @@
         <p:cNvGrpSpPr/>
         <p:nvPr/>
       </p:nvGrpSpPr>
-      <p:grpSpPr/>
+      <p:grpSpPr>
+        <a:xfrm>
+          <a:off x="0" y="0"/>
+          <a:ext cx="0" cy="0"/>
+          <a:chOff x="0" y="0"/>
+          <a:chExt cx="0" cy="0"/>
+        </a:xfrm>
+      </p:grpSpPr>
       <p:sp>
         <p:nvSpPr>
           <p:cNvPr id="2" name="Rectangle 1"/>
@@ -7811,6 +8035,7 @@
           <a:lstStyle/>
           <a:p>
             <a:pPr algn="ctr"/>
+            <a:endParaRPr/>
           </a:p>
         </p:txBody>
       </p:sp>
@@ -7877,7 +8102,7 @@
               </a:spcAft>
             </a:pPr>
             <a:r>
-              <a:rPr b="1" sz="1200">
+              <a:rPr sz="1200" b="1">
                 <a:solidFill>
                   <a:srgbClr val="14213D"/>
                 </a:solidFill>
@@ -7902,7 +8127,7 @@
               </a:spcAft>
             </a:pPr>
             <a:r>
-              <a:rPr b="1" sz="1200">
+              <a:rPr sz="1200" b="1">
                 <a:solidFill>
                   <a:srgbClr val="14213D"/>
                 </a:solidFill>
@@ -7927,7 +8152,7 @@
               </a:spcAft>
             </a:pPr>
             <a:r>
-              <a:rPr b="1" sz="1200">
+              <a:rPr sz="1200" b="1">
                 <a:solidFill>
                   <a:srgbClr val="14213D"/>
                 </a:solidFill>
@@ -7952,7 +8177,7 @@
               </a:spcAft>
             </a:pPr>
             <a:r>
-              <a:rPr b="1" sz="1200">
+              <a:rPr sz="1200" b="1">
                 <a:solidFill>
                   <a:srgbClr val="14213D"/>
                 </a:solidFill>
@@ -7977,7 +8202,7 @@
               </a:spcAft>
             </a:pPr>
             <a:r>
-              <a:rPr b="1" sz="1200">
+              <a:rPr sz="1200" b="1">
                 <a:solidFill>
                   <a:srgbClr val="14213D"/>
                 </a:solidFill>
@@ -8002,7 +8227,7 @@
               </a:spcAft>
             </a:pPr>
             <a:r>
-              <a:rPr b="1" sz="1200">
+              <a:rPr sz="1200" b="1">
                 <a:solidFill>
                   <a:srgbClr val="14213D"/>
                 </a:solidFill>
@@ -8060,7 +8285,7 @@
 </file>
 
 <file path=ppt/slides/slide25.xml><?xml version="1.0" encoding="utf-8"?>
-<p:sld xmlns:a="http://schemas.openxmlformats.org/drawingml/2006/main" xmlns:p="http://schemas.openxmlformats.org/presentationml/2006/main" xmlns:r="http://schemas.openxmlformats.org/officeDocument/2006/relationships">
+<p:sld xmlns:a="http://schemas.openxmlformats.org/drawingml/2006/main" xmlns:r="http://schemas.openxmlformats.org/officeDocument/2006/relationships" xmlns:p="http://schemas.openxmlformats.org/presentationml/2006/main">
   <p:cSld>
     <p:spTree>
       <p:nvGrpSpPr>
@@ -8068,7 +8293,14 @@
         <p:cNvGrpSpPr/>
         <p:nvPr/>
       </p:nvGrpSpPr>
-      <p:grpSpPr/>
+      <p:grpSpPr>
+        <a:xfrm>
+          <a:off x="0" y="0"/>
+          <a:ext cx="0" cy="0"/>
+          <a:chOff x="0" y="0"/>
+          <a:chExt cx="0" cy="0"/>
+        </a:xfrm>
+      </p:grpSpPr>
       <p:sp>
         <p:nvSpPr>
           <p:cNvPr id="2" name="Rectangle 1"/>
@@ -8109,6 +8341,7 @@
           <a:lstStyle/>
           <a:p>
             <a:pPr algn="ctr"/>
+            <a:endParaRPr/>
           </a:p>
         </p:txBody>
       </p:sp>
@@ -8191,7 +8424,7 @@
               </a:spcAft>
             </a:pPr>
             <a:r>
-              <a:rPr b="1" sz="1200">
+              <a:rPr sz="1200" b="1">
                 <a:solidFill>
                   <a:srgbClr val="14213D"/>
                 </a:solidFill>
@@ -8248,7 +8481,7 @@
               </a:spcAft>
             </a:pPr>
             <a:r>
-              <a:rPr b="1" sz="1200">
+              <a:rPr sz="1200" b="1">
                 <a:solidFill>
                   <a:srgbClr val="14213D"/>
                 </a:solidFill>
@@ -8306,7 +8539,7 @@
 </file>
 
 <file path=ppt/slides/slide26.xml><?xml version="1.0" encoding="utf-8"?>
-<p:sld xmlns:a="http://schemas.openxmlformats.org/drawingml/2006/main" xmlns:p="http://schemas.openxmlformats.org/presentationml/2006/main" xmlns:r="http://schemas.openxmlformats.org/officeDocument/2006/relationships">
+<p:sld xmlns:a="http://schemas.openxmlformats.org/drawingml/2006/main" xmlns:r="http://schemas.openxmlformats.org/officeDocument/2006/relationships" xmlns:p="http://schemas.openxmlformats.org/presentationml/2006/main">
   <p:cSld>
     <p:spTree>
       <p:nvGrpSpPr>
@@ -8314,7 +8547,14 @@
         <p:cNvGrpSpPr/>
         <p:nvPr/>
       </p:nvGrpSpPr>
-      <p:grpSpPr/>
+      <p:grpSpPr>
+        <a:xfrm>
+          <a:off x="0" y="0"/>
+          <a:ext cx="0" cy="0"/>
+          <a:chOff x="0" y="0"/>
+          <a:chExt cx="0" cy="0"/>
+        </a:xfrm>
+      </p:grpSpPr>
       <p:sp>
         <p:nvSpPr>
           <p:cNvPr id="2" name="Rectangle 1"/>
@@ -8355,6 +8595,7 @@
           <a:lstStyle/>
           <a:p>
             <a:pPr algn="ctr"/>
+            <a:endParaRPr/>
           </a:p>
         </p:txBody>
       </p:sp>
@@ -8518,7 +8759,7 @@
 </file>
 
 <file path=ppt/slides/slide27.xml><?xml version="1.0" encoding="utf-8"?>
-<p:sld xmlns:a="http://schemas.openxmlformats.org/drawingml/2006/main" xmlns:p="http://schemas.openxmlformats.org/presentationml/2006/main" xmlns:r="http://schemas.openxmlformats.org/officeDocument/2006/relationships">
+<p:sld xmlns:a="http://schemas.openxmlformats.org/drawingml/2006/main" xmlns:r="http://schemas.openxmlformats.org/officeDocument/2006/relationships" xmlns:p="http://schemas.openxmlformats.org/presentationml/2006/main">
   <p:cSld>
     <p:spTree>
       <p:nvGrpSpPr>
@@ -8526,7 +8767,14 @@
         <p:cNvGrpSpPr/>
         <p:nvPr/>
       </p:nvGrpSpPr>
-      <p:grpSpPr/>
+      <p:grpSpPr>
+        <a:xfrm>
+          <a:off x="0" y="0"/>
+          <a:ext cx="0" cy="0"/>
+          <a:chOff x="0" y="0"/>
+          <a:chExt cx="0" cy="0"/>
+        </a:xfrm>
+      </p:grpSpPr>
       <p:sp>
         <p:nvSpPr>
           <p:cNvPr id="2" name="Rectangle 1"/>
@@ -8567,6 +8815,7 @@
           <a:lstStyle/>
           <a:p>
             <a:pPr algn="ctr"/>
+            <a:endParaRPr/>
           </a:p>
         </p:txBody>
       </p:sp>
@@ -8610,6 +8859,7 @@
           <a:lstStyle/>
           <a:p>
             <a:pPr algn="ctr"/>
+            <a:endParaRPr/>
           </a:p>
         </p:txBody>
       </p:sp>
@@ -8727,7 +8977,7 @@
 </file>
 
 <file path=ppt/slides/slide28.xml><?xml version="1.0" encoding="utf-8"?>
-<p:sld xmlns:a="http://schemas.openxmlformats.org/drawingml/2006/main" xmlns:p="http://schemas.openxmlformats.org/presentationml/2006/main" xmlns:r="http://schemas.openxmlformats.org/officeDocument/2006/relationships">
+<p:sld xmlns:a="http://schemas.openxmlformats.org/drawingml/2006/main" xmlns:r="http://schemas.openxmlformats.org/officeDocument/2006/relationships" xmlns:p="http://schemas.openxmlformats.org/presentationml/2006/main">
   <p:cSld>
     <p:spTree>
       <p:nvGrpSpPr>
@@ -8735,7 +8985,14 @@
         <p:cNvGrpSpPr/>
         <p:nvPr/>
       </p:nvGrpSpPr>
-      <p:grpSpPr/>
+      <p:grpSpPr>
+        <a:xfrm>
+          <a:off x="0" y="0"/>
+          <a:ext cx="0" cy="0"/>
+          <a:chOff x="0" y="0"/>
+          <a:chExt cx="0" cy="0"/>
+        </a:xfrm>
+      </p:grpSpPr>
       <p:sp>
         <p:nvSpPr>
           <p:cNvPr id="2" name="Rectangle 1"/>
@@ -8776,6 +9033,7 @@
           <a:lstStyle/>
           <a:p>
             <a:pPr algn="ctr"/>
+            <a:endParaRPr/>
           </a:p>
         </p:txBody>
       </p:sp>
@@ -8842,7 +9100,7 @@
               </a:spcAft>
             </a:pPr>
             <a:r>
-              <a:rPr b="1" sz="1200">
+              <a:rPr sz="1200" b="1">
                 <a:solidFill>
                   <a:srgbClr val="14213D"/>
                 </a:solidFill>
@@ -8867,7 +9125,7 @@
               </a:spcAft>
             </a:pPr>
             <a:r>
-              <a:rPr b="1" sz="1200">
+              <a:rPr sz="1200" b="1">
                 <a:solidFill>
                   <a:srgbClr val="14213D"/>
                 </a:solidFill>
@@ -8892,7 +9150,7 @@
               </a:spcAft>
             </a:pPr>
             <a:r>
-              <a:rPr b="1" sz="1200">
+              <a:rPr sz="1200" b="1">
                 <a:solidFill>
                   <a:srgbClr val="14213D"/>
                 </a:solidFill>
@@ -8917,7 +9175,7 @@
               </a:spcAft>
             </a:pPr>
             <a:r>
-              <a:rPr b="1" sz="1200">
+              <a:rPr sz="1200" b="1">
                 <a:solidFill>
                   <a:srgbClr val="14213D"/>
                 </a:solidFill>
@@ -8942,7 +9200,7 @@
               </a:spcAft>
             </a:pPr>
             <a:r>
-              <a:rPr b="1" sz="1200">
+              <a:rPr sz="1200" b="1">
                 <a:solidFill>
                   <a:srgbClr val="14213D"/>
                 </a:solidFill>
@@ -8967,7 +9225,7 @@
               </a:spcAft>
             </a:pPr>
             <a:r>
-              <a:rPr b="1" sz="1200">
+              <a:rPr sz="1200" b="1">
                 <a:solidFill>
                   <a:srgbClr val="14213D"/>
                 </a:solidFill>
@@ -8992,7 +9250,7 @@
               </a:spcAft>
             </a:pPr>
             <a:r>
-              <a:rPr b="1" sz="1200">
+              <a:rPr sz="1200" b="1">
                 <a:solidFill>
                   <a:srgbClr val="14213D"/>
                 </a:solidFill>
@@ -9050,7 +9308,7 @@
 </file>
 
 <file path=ppt/slides/slide29.xml><?xml version="1.0" encoding="utf-8"?>
-<p:sld xmlns:a="http://schemas.openxmlformats.org/drawingml/2006/main" xmlns:p="http://schemas.openxmlformats.org/presentationml/2006/main" xmlns:r="http://schemas.openxmlformats.org/officeDocument/2006/relationships">
+<p:sld xmlns:a="http://schemas.openxmlformats.org/drawingml/2006/main" xmlns:r="http://schemas.openxmlformats.org/officeDocument/2006/relationships" xmlns:p="http://schemas.openxmlformats.org/presentationml/2006/main">
   <p:cSld>
     <p:spTree>
       <p:nvGrpSpPr>
@@ -9058,7 +9316,14 @@
         <p:cNvGrpSpPr/>
         <p:nvPr/>
       </p:nvGrpSpPr>
-      <p:grpSpPr/>
+      <p:grpSpPr>
+        <a:xfrm>
+          <a:off x="0" y="0"/>
+          <a:ext cx="0" cy="0"/>
+          <a:chOff x="0" y="0"/>
+          <a:chExt cx="0" cy="0"/>
+        </a:xfrm>
+      </p:grpSpPr>
       <p:sp>
         <p:nvSpPr>
           <p:cNvPr id="2" name="Rectangle 1"/>
@@ -9099,6 +9364,7 @@
           <a:lstStyle/>
           <a:p>
             <a:pPr algn="ctr"/>
+            <a:endParaRPr/>
           </a:p>
         </p:txBody>
       </p:sp>
@@ -9165,7 +9431,7 @@
               </a:spcAft>
             </a:pPr>
             <a:r>
-              <a:rPr b="1" sz="1200">
+              <a:rPr sz="1200" b="1">
                 <a:solidFill>
                   <a:srgbClr val="14213D"/>
                 </a:solidFill>
@@ -9190,7 +9456,7 @@
               </a:spcAft>
             </a:pPr>
             <a:r>
-              <a:rPr b="1" sz="1200">
+              <a:rPr sz="1200" b="1">
                 <a:solidFill>
                   <a:srgbClr val="14213D"/>
                 </a:solidFill>
@@ -9215,7 +9481,7 @@
               </a:spcAft>
             </a:pPr>
             <a:r>
-              <a:rPr b="1" sz="1200">
+              <a:rPr sz="1200" b="1">
                 <a:solidFill>
                   <a:srgbClr val="14213D"/>
                 </a:solidFill>
@@ -9240,7 +9506,7 @@
               </a:spcAft>
             </a:pPr>
             <a:r>
-              <a:rPr b="1" sz="1200">
+              <a:rPr sz="1200" b="1">
                 <a:solidFill>
                   <a:srgbClr val="14213D"/>
                 </a:solidFill>
@@ -9265,7 +9531,7 @@
               </a:spcAft>
             </a:pPr>
             <a:r>
-              <a:rPr b="1" sz="1200">
+              <a:rPr sz="1200" b="1">
                 <a:solidFill>
                   <a:srgbClr val="14213D"/>
                 </a:solidFill>
@@ -9290,7 +9556,7 @@
               </a:spcAft>
             </a:pPr>
             <a:r>
-              <a:rPr b="1" sz="1200">
+              <a:rPr sz="1200" b="1">
                 <a:solidFill>
                   <a:srgbClr val="14213D"/>
                 </a:solidFill>
@@ -9315,7 +9581,7 @@
               </a:spcAft>
             </a:pPr>
             <a:r>
-              <a:rPr b="1" sz="1200">
+              <a:rPr sz="1200" b="1">
                 <a:solidFill>
                   <a:srgbClr val="14213D"/>
                 </a:solidFill>
@@ -9340,7 +9606,7 @@
               </a:spcAft>
             </a:pPr>
             <a:r>
-              <a:rPr b="1" sz="1200">
+              <a:rPr sz="1200" b="1">
                 <a:solidFill>
                   <a:srgbClr val="14213D"/>
                 </a:solidFill>
@@ -9365,7 +9631,7 @@
               </a:spcAft>
             </a:pPr>
             <a:r>
-              <a:rPr b="1" sz="1200">
+              <a:rPr sz="1200" b="1">
                 <a:solidFill>
                   <a:srgbClr val="14213D"/>
                 </a:solidFill>
@@ -9423,7 +9689,7 @@
 </file>
 
 <file path=ppt/slides/slide3.xml><?xml version="1.0" encoding="utf-8"?>
-<p:sld xmlns:a="http://schemas.openxmlformats.org/drawingml/2006/main" xmlns:p="http://schemas.openxmlformats.org/presentationml/2006/main" xmlns:r="http://schemas.openxmlformats.org/officeDocument/2006/relationships">
+<p:sld xmlns:a="http://schemas.openxmlformats.org/drawingml/2006/main" xmlns:r="http://schemas.openxmlformats.org/officeDocument/2006/relationships" xmlns:p="http://schemas.openxmlformats.org/presentationml/2006/main">
   <p:cSld>
     <p:spTree>
       <p:nvGrpSpPr>
@@ -9431,7 +9697,14 @@
         <p:cNvGrpSpPr/>
         <p:nvPr/>
       </p:nvGrpSpPr>
-      <p:grpSpPr/>
+      <p:grpSpPr>
+        <a:xfrm>
+          <a:off x="0" y="0"/>
+          <a:ext cx="0" cy="0"/>
+          <a:chOff x="0" y="0"/>
+          <a:chExt cx="0" cy="0"/>
+        </a:xfrm>
+      </p:grpSpPr>
       <p:sp>
         <p:nvSpPr>
           <p:cNvPr id="2" name="Rectangle 1"/>
@@ -9472,6 +9745,7 @@
           <a:lstStyle/>
           <a:p>
             <a:pPr algn="ctr"/>
+            <a:endParaRPr/>
           </a:p>
         </p:txBody>
       </p:sp>
@@ -9573,7 +9847,7 @@
               </a:spcAft>
             </a:pPr>
             <a:r>
-              <a:rPr b="1" sz="1400">
+              <a:rPr sz="1400" b="1">
                 <a:solidFill>
                   <a:srgbClr val="14213D"/>
                 </a:solidFill>
@@ -9598,7 +9872,7 @@
               </a:spcAft>
             </a:pPr>
             <a:r>
-              <a:rPr b="1" sz="1400">
+              <a:rPr sz="1400" b="1">
                 <a:solidFill>
                   <a:srgbClr val="14213D"/>
                 </a:solidFill>
@@ -9623,7 +9897,7 @@
               </a:spcAft>
             </a:pPr>
             <a:r>
-              <a:rPr b="1" sz="1400">
+              <a:rPr sz="1400" b="1">
                 <a:solidFill>
                   <a:srgbClr val="14213D"/>
                 </a:solidFill>
@@ -9648,7 +9922,7 @@
               </a:spcAft>
             </a:pPr>
             <a:r>
-              <a:rPr b="1" sz="1400">
+              <a:rPr sz="1400" b="1">
                 <a:solidFill>
                   <a:srgbClr val="14213D"/>
                 </a:solidFill>
@@ -9673,7 +9947,7 @@
               </a:spcAft>
             </a:pPr>
             <a:r>
-              <a:rPr b="1" sz="1400">
+              <a:rPr sz="1400" b="1">
                 <a:solidFill>
                   <a:srgbClr val="14213D"/>
                 </a:solidFill>
@@ -9698,7 +9972,7 @@
               </a:spcAft>
             </a:pPr>
             <a:r>
-              <a:rPr b="1" sz="1400">
+              <a:rPr sz="1400" b="1">
                 <a:solidFill>
                   <a:srgbClr val="14213D"/>
                 </a:solidFill>
@@ -9723,7 +9997,7 @@
               </a:spcAft>
             </a:pPr>
             <a:r>
-              <a:rPr b="1" sz="1400">
+              <a:rPr sz="1400" b="1">
                 <a:solidFill>
                   <a:srgbClr val="14213D"/>
                 </a:solidFill>
@@ -9752,7 +10026,7 @@
 </file>
 
 <file path=ppt/slides/slide30.xml><?xml version="1.0" encoding="utf-8"?>
-<p:sld xmlns:a="http://schemas.openxmlformats.org/drawingml/2006/main" xmlns:p="http://schemas.openxmlformats.org/presentationml/2006/main" xmlns:r="http://schemas.openxmlformats.org/officeDocument/2006/relationships">
+<p:sld xmlns:a="http://schemas.openxmlformats.org/drawingml/2006/main" xmlns:r="http://schemas.openxmlformats.org/officeDocument/2006/relationships" xmlns:p="http://schemas.openxmlformats.org/presentationml/2006/main">
   <p:cSld>
     <p:spTree>
       <p:nvGrpSpPr>
@@ -9760,7 +10034,14 @@
         <p:cNvGrpSpPr/>
         <p:nvPr/>
       </p:nvGrpSpPr>
-      <p:grpSpPr/>
+      <p:grpSpPr>
+        <a:xfrm>
+          <a:off x="0" y="0"/>
+          <a:ext cx="0" cy="0"/>
+          <a:chOff x="0" y="0"/>
+          <a:chExt cx="0" cy="0"/>
+        </a:xfrm>
+      </p:grpSpPr>
       <p:sp>
         <p:nvSpPr>
           <p:cNvPr id="2" name="Rectangle 1"/>
@@ -9801,6 +10082,7 @@
           <a:lstStyle/>
           <a:p>
             <a:pPr algn="ctr"/>
+            <a:endParaRPr/>
           </a:p>
         </p:txBody>
       </p:sp>
@@ -9883,7 +10165,7 @@
               </a:spcAft>
             </a:pPr>
             <a:r>
-              <a:rPr b="1" sz="1200">
+              <a:rPr sz="1200" b="1">
                 <a:solidFill>
                   <a:srgbClr val="14213D"/>
                 </a:solidFill>
@@ -9908,7 +10190,7 @@
               </a:spcAft>
             </a:pPr>
             <a:r>
-              <a:rPr b="1" sz="1200">
+              <a:rPr sz="1200" b="1">
                 <a:solidFill>
                   <a:srgbClr val="14213D"/>
                 </a:solidFill>
@@ -10014,7 +10296,7 @@
 </file>
 
 <file path=ppt/slides/slide31.xml><?xml version="1.0" encoding="utf-8"?>
-<p:sld xmlns:a="http://schemas.openxmlformats.org/drawingml/2006/main" xmlns:p="http://schemas.openxmlformats.org/presentationml/2006/main" xmlns:r="http://schemas.openxmlformats.org/officeDocument/2006/relationships">
+<p:sld xmlns:a="http://schemas.openxmlformats.org/drawingml/2006/main" xmlns:r="http://schemas.openxmlformats.org/officeDocument/2006/relationships" xmlns:p="http://schemas.openxmlformats.org/presentationml/2006/main">
   <p:cSld>
     <p:spTree>
       <p:nvGrpSpPr>
@@ -10022,7 +10304,14 @@
         <p:cNvGrpSpPr/>
         <p:nvPr/>
       </p:nvGrpSpPr>
-      <p:grpSpPr/>
+      <p:grpSpPr>
+        <a:xfrm>
+          <a:off x="0" y="0"/>
+          <a:ext cx="0" cy="0"/>
+          <a:chOff x="0" y="0"/>
+          <a:chExt cx="0" cy="0"/>
+        </a:xfrm>
+      </p:grpSpPr>
       <p:sp>
         <p:nvSpPr>
           <p:cNvPr id="2" name="Rectangle 1"/>
@@ -10063,6 +10352,7 @@
           <a:lstStyle/>
           <a:p>
             <a:pPr algn="ctr"/>
+            <a:endParaRPr/>
           </a:p>
         </p:txBody>
       </p:sp>
@@ -10129,7 +10419,7 @@
               </a:spcAft>
             </a:pPr>
             <a:r>
-              <a:rPr b="1" sz="1200">
+              <a:rPr sz="1200" b="1">
                 <a:solidFill>
                   <a:srgbClr val="14213D"/>
                 </a:solidFill>
@@ -10170,7 +10460,7 @@
               </a:spcAft>
             </a:pPr>
             <a:r>
-              <a:rPr b="1" sz="1100">
+              <a:rPr sz="1100" b="1">
                 <a:solidFill>
                   <a:srgbClr val="14213D"/>
                 </a:solidFill>
@@ -10195,7 +10485,7 @@
               </a:spcAft>
             </a:pPr>
             <a:r>
-              <a:rPr b="1" sz="1100">
+              <a:rPr sz="1100" b="1">
                 <a:solidFill>
                   <a:srgbClr val="14213D"/>
                 </a:solidFill>
@@ -10220,7 +10510,7 @@
               </a:spcAft>
             </a:pPr>
             <a:r>
-              <a:rPr b="1" sz="1200">
+              <a:rPr sz="1200" b="1">
                 <a:solidFill>
                   <a:srgbClr val="14213D"/>
                 </a:solidFill>
@@ -10245,7 +10535,7 @@
               </a:spcAft>
             </a:pPr>
             <a:r>
-              <a:rPr b="1" sz="1100">
+              <a:rPr sz="1100" b="1">
                 <a:solidFill>
                   <a:srgbClr val="14213D"/>
                 </a:solidFill>
@@ -10319,7 +10609,7 @@
 </file>
 
 <file path=ppt/slides/slide32.xml><?xml version="1.0" encoding="utf-8"?>
-<p:sld xmlns:a="http://schemas.openxmlformats.org/drawingml/2006/main" xmlns:p="http://schemas.openxmlformats.org/presentationml/2006/main" xmlns:r="http://schemas.openxmlformats.org/officeDocument/2006/relationships">
+<p:sld xmlns:a="http://schemas.openxmlformats.org/drawingml/2006/main" xmlns:r="http://schemas.openxmlformats.org/officeDocument/2006/relationships" xmlns:p="http://schemas.openxmlformats.org/presentationml/2006/main">
   <p:cSld>
     <p:spTree>
       <p:nvGrpSpPr>
@@ -10327,7 +10617,14 @@
         <p:cNvGrpSpPr/>
         <p:nvPr/>
       </p:nvGrpSpPr>
-      <p:grpSpPr/>
+      <p:grpSpPr>
+        <a:xfrm>
+          <a:off x="0" y="0"/>
+          <a:ext cx="0" cy="0"/>
+          <a:chOff x="0" y="0"/>
+          <a:chExt cx="0" cy="0"/>
+        </a:xfrm>
+      </p:grpSpPr>
       <p:sp>
         <p:nvSpPr>
           <p:cNvPr id="2" name="Rectangle 1"/>
@@ -10368,6 +10665,7 @@
           <a:lstStyle/>
           <a:p>
             <a:pPr algn="ctr"/>
+            <a:endParaRPr/>
           </a:p>
         </p:txBody>
       </p:sp>
@@ -10434,7 +10732,7 @@
               </a:spcAft>
             </a:pPr>
             <a:r>
-              <a:rPr b="1" sz="1200">
+              <a:rPr sz="1200" b="1">
                 <a:solidFill>
                   <a:srgbClr val="14213D"/>
                 </a:solidFill>
@@ -10459,7 +10757,7 @@
               </a:spcAft>
             </a:pPr>
             <a:r>
-              <a:rPr b="1" sz="1200">
+              <a:rPr sz="1200" b="1">
                 <a:solidFill>
                   <a:srgbClr val="14213D"/>
                 </a:solidFill>
@@ -10484,7 +10782,7 @@
               </a:spcAft>
             </a:pPr>
             <a:r>
-              <a:rPr b="1" sz="1200">
+              <a:rPr sz="1200" b="1">
                 <a:solidFill>
                   <a:srgbClr val="14213D"/>
                 </a:solidFill>
@@ -10509,7 +10807,7 @@
               </a:spcAft>
             </a:pPr>
             <a:r>
-              <a:rPr b="1" sz="1200">
+              <a:rPr sz="1200" b="1">
                 <a:solidFill>
                   <a:srgbClr val="14213D"/>
                 </a:solidFill>
@@ -10583,7 +10881,7 @@
 </file>
 
 <file path=ppt/slides/slide33.xml><?xml version="1.0" encoding="utf-8"?>
-<p:sld xmlns:a="http://schemas.openxmlformats.org/drawingml/2006/main" xmlns:p="http://schemas.openxmlformats.org/presentationml/2006/main" xmlns:r="http://schemas.openxmlformats.org/officeDocument/2006/relationships">
+<p:sld xmlns:a="http://schemas.openxmlformats.org/drawingml/2006/main" xmlns:r="http://schemas.openxmlformats.org/officeDocument/2006/relationships" xmlns:p="http://schemas.openxmlformats.org/presentationml/2006/main">
   <p:cSld>
     <p:spTree>
       <p:nvGrpSpPr>
@@ -10591,7 +10889,14 @@
         <p:cNvGrpSpPr/>
         <p:nvPr/>
       </p:nvGrpSpPr>
-      <p:grpSpPr/>
+      <p:grpSpPr>
+        <a:xfrm>
+          <a:off x="0" y="0"/>
+          <a:ext cx="0" cy="0"/>
+          <a:chOff x="0" y="0"/>
+          <a:chExt cx="0" cy="0"/>
+        </a:xfrm>
+      </p:grpSpPr>
       <p:sp>
         <p:nvSpPr>
           <p:cNvPr id="2" name="Rectangle 1"/>
@@ -10632,6 +10937,7 @@
           <a:lstStyle/>
           <a:p>
             <a:pPr algn="ctr"/>
+            <a:endParaRPr/>
           </a:p>
         </p:txBody>
       </p:sp>
@@ -10675,6 +10981,7 @@
           <a:lstStyle/>
           <a:p>
             <a:pPr algn="ctr"/>
+            <a:endParaRPr/>
           </a:p>
         </p:txBody>
       </p:sp>
@@ -10792,7 +11099,7 @@
 </file>
 
 <file path=ppt/slides/slide34.xml><?xml version="1.0" encoding="utf-8"?>
-<p:sld xmlns:a="http://schemas.openxmlformats.org/drawingml/2006/main" xmlns:p="http://schemas.openxmlformats.org/presentationml/2006/main" xmlns:r="http://schemas.openxmlformats.org/officeDocument/2006/relationships">
+<p:sld xmlns:a="http://schemas.openxmlformats.org/drawingml/2006/main" xmlns:r="http://schemas.openxmlformats.org/officeDocument/2006/relationships" xmlns:p="http://schemas.openxmlformats.org/presentationml/2006/main">
   <p:cSld>
     <p:spTree>
       <p:nvGrpSpPr>
@@ -10800,7 +11107,14 @@
         <p:cNvGrpSpPr/>
         <p:nvPr/>
       </p:nvGrpSpPr>
-      <p:grpSpPr/>
+      <p:grpSpPr>
+        <a:xfrm>
+          <a:off x="0" y="0"/>
+          <a:ext cx="0" cy="0"/>
+          <a:chOff x="0" y="0"/>
+          <a:chExt cx="0" cy="0"/>
+        </a:xfrm>
+      </p:grpSpPr>
       <p:sp>
         <p:nvSpPr>
           <p:cNvPr id="2" name="Rectangle 1"/>
@@ -10841,6 +11155,7 @@
           <a:lstStyle/>
           <a:p>
             <a:pPr algn="ctr"/>
+            <a:endParaRPr/>
           </a:p>
         </p:txBody>
       </p:sp>
@@ -10907,7 +11222,7 @@
               </a:spcAft>
             </a:pPr>
             <a:r>
-              <a:rPr b="1" sz="1200">
+              <a:rPr sz="1200" b="1">
                 <a:solidFill>
                   <a:srgbClr val="14213D"/>
                 </a:solidFill>
@@ -10932,7 +11247,7 @@
               </a:spcAft>
             </a:pPr>
             <a:r>
-              <a:rPr b="1" sz="1200">
+              <a:rPr sz="1200" b="1">
                 <a:solidFill>
                   <a:srgbClr val="14213D"/>
                 </a:solidFill>
@@ -10957,7 +11272,7 @@
               </a:spcAft>
             </a:pPr>
             <a:r>
-              <a:rPr b="1" sz="1200">
+              <a:rPr sz="1200" b="1">
                 <a:solidFill>
                   <a:srgbClr val="14213D"/>
                 </a:solidFill>
@@ -10982,7 +11297,7 @@
               </a:spcAft>
             </a:pPr>
             <a:r>
-              <a:rPr b="1" sz="1200">
+              <a:rPr sz="1200" b="1">
                 <a:solidFill>
                   <a:srgbClr val="14213D"/>
                 </a:solidFill>
@@ -11056,7 +11371,7 @@
 </file>
 
 <file path=ppt/slides/slide35.xml><?xml version="1.0" encoding="utf-8"?>
-<p:sld xmlns:a="http://schemas.openxmlformats.org/drawingml/2006/main" xmlns:p="http://schemas.openxmlformats.org/presentationml/2006/main" xmlns:r="http://schemas.openxmlformats.org/officeDocument/2006/relationships">
+<p:sld xmlns:a="http://schemas.openxmlformats.org/drawingml/2006/main" xmlns:r="http://schemas.openxmlformats.org/officeDocument/2006/relationships" xmlns:p="http://schemas.openxmlformats.org/presentationml/2006/main">
   <p:cSld>
     <p:spTree>
       <p:nvGrpSpPr>
@@ -11064,7 +11379,14 @@
         <p:cNvGrpSpPr/>
         <p:nvPr/>
       </p:nvGrpSpPr>
-      <p:grpSpPr/>
+      <p:grpSpPr>
+        <a:xfrm>
+          <a:off x="0" y="0"/>
+          <a:ext cx="0" cy="0"/>
+          <a:chOff x="0" y="0"/>
+          <a:chExt cx="0" cy="0"/>
+        </a:xfrm>
+      </p:grpSpPr>
       <p:sp>
         <p:nvSpPr>
           <p:cNvPr id="2" name="Rectangle 1"/>
@@ -11105,6 +11427,7 @@
           <a:lstStyle/>
           <a:p>
             <a:pPr algn="ctr"/>
+            <a:endParaRPr/>
           </a:p>
         </p:txBody>
       </p:sp>
@@ -11171,7 +11494,7 @@
               </a:spcAft>
             </a:pPr>
             <a:r>
-              <a:rPr b="1" sz="1200">
+              <a:rPr sz="1200" b="1">
                 <a:solidFill>
                   <a:srgbClr val="14213D"/>
                 </a:solidFill>
@@ -11196,7 +11519,7 @@
               </a:spcAft>
             </a:pPr>
             <a:r>
-              <a:rPr b="1" sz="1100">
+              <a:rPr sz="1100" b="1">
                 <a:solidFill>
                   <a:srgbClr val="14213D"/>
                 </a:solidFill>
@@ -11221,7 +11544,7 @@
               </a:spcAft>
             </a:pPr>
             <a:r>
-              <a:rPr b="1" sz="1100">
+              <a:rPr sz="1100" b="1">
                 <a:solidFill>
                   <a:srgbClr val="14213D"/>
                 </a:solidFill>
@@ -11262,7 +11585,7 @@
               </a:spcAft>
             </a:pPr>
             <a:r>
-              <a:rPr b="1" sz="1200">
+              <a:rPr sz="1200" b="1">
                 <a:solidFill>
                   <a:srgbClr val="14213D"/>
                 </a:solidFill>
@@ -11287,7 +11610,7 @@
               </a:spcAft>
             </a:pPr>
             <a:r>
-              <a:rPr b="1" sz="1200">
+              <a:rPr sz="1200" b="1">
                 <a:solidFill>
                   <a:srgbClr val="14213D"/>
                 </a:solidFill>
@@ -11312,7 +11635,7 @@
               </a:spcAft>
             </a:pPr>
             <a:r>
-              <a:rPr b="1" sz="1200">
+              <a:rPr sz="1200" b="1">
                 <a:solidFill>
                   <a:srgbClr val="14213D"/>
                 </a:solidFill>
@@ -11370,7 +11693,7 @@
 </file>
 
 <file path=ppt/slides/slide36.xml><?xml version="1.0" encoding="utf-8"?>
-<p:sld xmlns:a="http://schemas.openxmlformats.org/drawingml/2006/main" xmlns:p="http://schemas.openxmlformats.org/presentationml/2006/main" xmlns:r="http://schemas.openxmlformats.org/officeDocument/2006/relationships">
+<p:sld xmlns:a="http://schemas.openxmlformats.org/drawingml/2006/main" xmlns:r="http://schemas.openxmlformats.org/officeDocument/2006/relationships" xmlns:p="http://schemas.openxmlformats.org/presentationml/2006/main">
   <p:cSld>
     <p:spTree>
       <p:nvGrpSpPr>
@@ -11378,7 +11701,14 @@
         <p:cNvGrpSpPr/>
         <p:nvPr/>
       </p:nvGrpSpPr>
-      <p:grpSpPr/>
+      <p:grpSpPr>
+        <a:xfrm>
+          <a:off x="0" y="0"/>
+          <a:ext cx="0" cy="0"/>
+          <a:chOff x="0" y="0"/>
+          <a:chExt cx="0" cy="0"/>
+        </a:xfrm>
+      </p:grpSpPr>
       <p:sp>
         <p:nvSpPr>
           <p:cNvPr id="2" name="Rectangle 1"/>
@@ -11419,6 +11749,7 @@
           <a:lstStyle/>
           <a:p>
             <a:pPr algn="ctr"/>
+            <a:endParaRPr/>
           </a:p>
         </p:txBody>
       </p:sp>
@@ -11462,6 +11793,7 @@
           <a:lstStyle/>
           <a:p>
             <a:pPr algn="ctr"/>
+            <a:endParaRPr/>
           </a:p>
         </p:txBody>
       </p:sp>
@@ -11579,7 +11911,7 @@
 </file>
 
 <file path=ppt/slides/slide37.xml><?xml version="1.0" encoding="utf-8"?>
-<p:sld xmlns:a="http://schemas.openxmlformats.org/drawingml/2006/main" xmlns:p="http://schemas.openxmlformats.org/presentationml/2006/main" xmlns:r="http://schemas.openxmlformats.org/officeDocument/2006/relationships">
+<p:sld xmlns:a="http://schemas.openxmlformats.org/drawingml/2006/main" xmlns:r="http://schemas.openxmlformats.org/officeDocument/2006/relationships" xmlns:p="http://schemas.openxmlformats.org/presentationml/2006/main">
   <p:cSld>
     <p:spTree>
       <p:nvGrpSpPr>
@@ -11587,7 +11919,14 @@
         <p:cNvGrpSpPr/>
         <p:nvPr/>
       </p:nvGrpSpPr>
-      <p:grpSpPr/>
+      <p:grpSpPr>
+        <a:xfrm>
+          <a:off x="0" y="0"/>
+          <a:ext cx="0" cy="0"/>
+          <a:chOff x="0" y="0"/>
+          <a:chExt cx="0" cy="0"/>
+        </a:xfrm>
+      </p:grpSpPr>
       <p:sp>
         <p:nvSpPr>
           <p:cNvPr id="2" name="Rectangle 1"/>
@@ -11628,6 +11967,7 @@
           <a:lstStyle/>
           <a:p>
             <a:pPr algn="ctr"/>
+            <a:endParaRPr/>
           </a:p>
         </p:txBody>
       </p:sp>
@@ -11726,7 +12066,7 @@
               </a:spcAft>
             </a:pPr>
             <a:r>
-              <a:rPr b="1" sz="1200">
+              <a:rPr sz="1200" b="1">
                 <a:solidFill>
                   <a:srgbClr val="14213D"/>
                 </a:solidFill>
@@ -11751,7 +12091,7 @@
               </a:spcAft>
             </a:pPr>
             <a:r>
-              <a:rPr b="1" sz="1200">
+              <a:rPr sz="1200" b="1">
                 <a:solidFill>
                   <a:srgbClr val="14213D"/>
                 </a:solidFill>
@@ -11776,7 +12116,7 @@
               </a:spcAft>
             </a:pPr>
             <a:r>
-              <a:rPr b="1" sz="1200">
+              <a:rPr sz="1200" b="1">
                 <a:solidFill>
                   <a:srgbClr val="14213D"/>
                 </a:solidFill>
@@ -11850,7 +12190,7 @@
 </file>
 
 <file path=ppt/slides/slide38.xml><?xml version="1.0" encoding="utf-8"?>
-<p:sld xmlns:a="http://schemas.openxmlformats.org/drawingml/2006/main" xmlns:p="http://schemas.openxmlformats.org/presentationml/2006/main" xmlns:r="http://schemas.openxmlformats.org/officeDocument/2006/relationships">
+<p:sld xmlns:a="http://schemas.openxmlformats.org/drawingml/2006/main" xmlns:r="http://schemas.openxmlformats.org/officeDocument/2006/relationships" xmlns:p="http://schemas.openxmlformats.org/presentationml/2006/main">
   <p:cSld>
     <p:spTree>
       <p:nvGrpSpPr>
@@ -11858,7 +12198,14 @@
         <p:cNvGrpSpPr/>
         <p:nvPr/>
       </p:nvGrpSpPr>
-      <p:grpSpPr/>
+      <p:grpSpPr>
+        <a:xfrm>
+          <a:off x="0" y="0"/>
+          <a:ext cx="0" cy="0"/>
+          <a:chOff x="0" y="0"/>
+          <a:chExt cx="0" cy="0"/>
+        </a:xfrm>
+      </p:grpSpPr>
       <p:sp>
         <p:nvSpPr>
           <p:cNvPr id="2" name="Rectangle 1"/>
@@ -11899,6 +12246,7 @@
           <a:lstStyle/>
           <a:p>
             <a:pPr algn="ctr"/>
+            <a:endParaRPr/>
           </a:p>
         </p:txBody>
       </p:sp>
@@ -11965,7 +12313,7 @@
               </a:spcAft>
             </a:pPr>
             <a:r>
-              <a:rPr b="1" sz="1150">
+              <a:rPr sz="1150" b="1">
                 <a:solidFill>
                   <a:srgbClr val="14213D"/>
                 </a:solidFill>
@@ -11990,7 +12338,7 @@
               </a:spcAft>
             </a:pPr>
             <a:r>
-              <a:rPr b="1" sz="1050">
+              <a:rPr sz="1050" b="1">
                 <a:solidFill>
                   <a:srgbClr val="14213D"/>
                 </a:solidFill>
@@ -12015,7 +12363,7 @@
               </a:spcAft>
             </a:pPr>
             <a:r>
-              <a:rPr b="1" sz="1050">
+              <a:rPr sz="1050" b="1">
                 <a:solidFill>
                   <a:srgbClr val="14213D"/>
                 </a:solidFill>
@@ -12040,7 +12388,7 @@
               </a:spcAft>
             </a:pPr>
             <a:r>
-              <a:rPr b="1" sz="1150">
+              <a:rPr sz="1150" b="1">
                 <a:solidFill>
                   <a:srgbClr val="14213D"/>
                 </a:solidFill>
@@ -12065,7 +12413,7 @@
               </a:spcAft>
             </a:pPr>
             <a:r>
-              <a:rPr b="1" sz="1150">
+              <a:rPr sz="1150" b="1">
                 <a:solidFill>
                   <a:srgbClr val="14213D"/>
                 </a:solidFill>
@@ -12090,7 +12438,7 @@
               </a:spcAft>
             </a:pPr>
             <a:r>
-              <a:rPr b="1" sz="1150">
+              <a:rPr sz="1150" b="1">
                 <a:solidFill>
                   <a:srgbClr val="14213D"/>
                 </a:solidFill>
@@ -12115,7 +12463,7 @@
               </a:spcAft>
             </a:pPr>
             <a:r>
-              <a:rPr b="1" sz="1150">
+              <a:rPr sz="1150" b="1">
                 <a:solidFill>
                   <a:srgbClr val="14213D"/>
                 </a:solidFill>
@@ -12140,7 +12488,7 @@
               </a:spcAft>
             </a:pPr>
             <a:r>
-              <a:rPr b="1" sz="1150">
+              <a:rPr sz="1150" b="1">
                 <a:solidFill>
                   <a:srgbClr val="14213D"/>
                 </a:solidFill>
@@ -12198,7 +12546,7 @@
 </file>
 
 <file path=ppt/slides/slide39.xml><?xml version="1.0" encoding="utf-8"?>
-<p:sld xmlns:a="http://schemas.openxmlformats.org/drawingml/2006/main" xmlns:p="http://schemas.openxmlformats.org/presentationml/2006/main" xmlns:r="http://schemas.openxmlformats.org/officeDocument/2006/relationships">
+<p:sld xmlns:a="http://schemas.openxmlformats.org/drawingml/2006/main" xmlns:r="http://schemas.openxmlformats.org/officeDocument/2006/relationships" xmlns:p="http://schemas.openxmlformats.org/presentationml/2006/main">
   <p:cSld>
     <p:spTree>
       <p:nvGrpSpPr>
@@ -12206,7 +12554,14 @@
         <p:cNvGrpSpPr/>
         <p:nvPr/>
       </p:nvGrpSpPr>
-      <p:grpSpPr/>
+      <p:grpSpPr>
+        <a:xfrm>
+          <a:off x="0" y="0"/>
+          <a:ext cx="0" cy="0"/>
+          <a:chOff x="0" y="0"/>
+          <a:chExt cx="0" cy="0"/>
+        </a:xfrm>
+      </p:grpSpPr>
       <p:sp>
         <p:nvSpPr>
           <p:cNvPr id="2" name="Rectangle 1"/>
@@ -12247,6 +12602,7 @@
           <a:lstStyle/>
           <a:p>
             <a:pPr algn="ctr"/>
+            <a:endParaRPr/>
           </a:p>
         </p:txBody>
       </p:sp>
@@ -12313,7 +12669,7 @@
               </a:spcAft>
             </a:pPr>
             <a:r>
-              <a:rPr b="1" sz="1150">
+              <a:rPr sz="1150" b="1">
                 <a:solidFill>
                   <a:srgbClr val="14213D"/>
                 </a:solidFill>
@@ -12338,7 +12694,7 @@
               </a:spcAft>
             </a:pPr>
             <a:r>
-              <a:rPr b="1" sz="1050">
+              <a:rPr sz="1050" b="1">
                 <a:solidFill>
                   <a:srgbClr val="14213D"/>
                 </a:solidFill>
@@ -12363,7 +12719,7 @@
               </a:spcAft>
             </a:pPr>
             <a:r>
-              <a:rPr b="1" sz="1050">
+              <a:rPr sz="1050" b="1">
                 <a:solidFill>
                   <a:srgbClr val="14213D"/>
                 </a:solidFill>
@@ -12388,7 +12744,7 @@
               </a:spcAft>
             </a:pPr>
             <a:r>
-              <a:rPr b="1" sz="1050">
+              <a:rPr sz="1050" b="1">
                 <a:solidFill>
                   <a:srgbClr val="14213D"/>
                 </a:solidFill>
@@ -12413,7 +12769,7 @@
               </a:spcAft>
             </a:pPr>
             <a:r>
-              <a:rPr b="1" sz="1050">
+              <a:rPr sz="1050" b="1">
                 <a:solidFill>
                   <a:srgbClr val="14213D"/>
                 </a:solidFill>
@@ -12438,7 +12794,7 @@
               </a:spcAft>
             </a:pPr>
             <a:r>
-              <a:rPr b="1" sz="1150">
+              <a:rPr sz="1150" b="1">
                 <a:solidFill>
                   <a:srgbClr val="14213D"/>
                 </a:solidFill>
@@ -12463,7 +12819,7 @@
               </a:spcAft>
             </a:pPr>
             <a:r>
-              <a:rPr b="1" sz="1150">
+              <a:rPr sz="1150" b="1">
                 <a:solidFill>
                   <a:srgbClr val="14213D"/>
                 </a:solidFill>
@@ -12537,7 +12893,7 @@
 </file>
 
 <file path=ppt/slides/slide4.xml><?xml version="1.0" encoding="utf-8"?>
-<p:sld xmlns:a="http://schemas.openxmlformats.org/drawingml/2006/main" xmlns:p="http://schemas.openxmlformats.org/presentationml/2006/main" xmlns:r="http://schemas.openxmlformats.org/officeDocument/2006/relationships">
+<p:sld xmlns:a="http://schemas.openxmlformats.org/drawingml/2006/main" xmlns:r="http://schemas.openxmlformats.org/officeDocument/2006/relationships" xmlns:p="http://schemas.openxmlformats.org/presentationml/2006/main">
   <p:cSld>
     <p:spTree>
       <p:nvGrpSpPr>
@@ -12545,7 +12901,14 @@
         <p:cNvGrpSpPr/>
         <p:nvPr/>
       </p:nvGrpSpPr>
-      <p:grpSpPr/>
+      <p:grpSpPr>
+        <a:xfrm>
+          <a:off x="0" y="0"/>
+          <a:ext cx="0" cy="0"/>
+          <a:chOff x="0" y="0"/>
+          <a:chExt cx="0" cy="0"/>
+        </a:xfrm>
+      </p:grpSpPr>
       <p:sp>
         <p:nvSpPr>
           <p:cNvPr id="2" name="Rectangle 1"/>
@@ -12586,6 +12949,7 @@
           <a:lstStyle/>
           <a:p>
             <a:pPr algn="ctr"/>
+            <a:endParaRPr/>
           </a:p>
         </p:txBody>
       </p:sp>
@@ -12652,7 +13016,7 @@
               </a:spcAft>
             </a:pPr>
             <a:r>
-              <a:rPr b="1" sz="1400">
+              <a:rPr sz="1400" b="1">
                 <a:solidFill>
                   <a:srgbClr val="14213D"/>
                 </a:solidFill>
@@ -12677,7 +13041,7 @@
               </a:spcAft>
             </a:pPr>
             <a:r>
-              <a:rPr b="1" sz="1400">
+              <a:rPr sz="1400" b="1">
                 <a:solidFill>
                   <a:srgbClr val="14213D"/>
                 </a:solidFill>
@@ -12702,7 +13066,7 @@
               </a:spcAft>
             </a:pPr>
             <a:r>
-              <a:rPr b="1" sz="1400">
+              <a:rPr sz="1400" b="1">
                 <a:solidFill>
                   <a:srgbClr val="14213D"/>
                 </a:solidFill>
@@ -12727,7 +13091,7 @@
               </a:spcAft>
             </a:pPr>
             <a:r>
-              <a:rPr b="1" sz="1400">
+              <a:rPr sz="1400" b="1">
                 <a:solidFill>
                   <a:srgbClr val="14213D"/>
                 </a:solidFill>
@@ -12752,7 +13116,7 @@
               </a:spcAft>
             </a:pPr>
             <a:r>
-              <a:rPr b="1" sz="1400">
+              <a:rPr sz="1400" b="1">
                 <a:solidFill>
                   <a:srgbClr val="14213D"/>
                 </a:solidFill>
@@ -12777,7 +13141,7 @@
               </a:spcAft>
             </a:pPr>
             <a:r>
-              <a:rPr b="1" sz="1400">
+              <a:rPr sz="1400" b="1">
                 <a:solidFill>
                   <a:srgbClr val="14213D"/>
                 </a:solidFill>
@@ -12802,7 +13166,7 @@
               </a:spcAft>
             </a:pPr>
             <a:r>
-              <a:rPr b="1" sz="1400">
+              <a:rPr sz="1400" b="1">
                 <a:solidFill>
                   <a:srgbClr val="14213D"/>
                 </a:solidFill>
@@ -12831,7 +13195,7 @@
 </file>
 
 <file path=ppt/slides/slide40.xml><?xml version="1.0" encoding="utf-8"?>
-<p:sld xmlns:a="http://schemas.openxmlformats.org/drawingml/2006/main" xmlns:p="http://schemas.openxmlformats.org/presentationml/2006/main" xmlns:r="http://schemas.openxmlformats.org/officeDocument/2006/relationships">
+<p:sld xmlns:a="http://schemas.openxmlformats.org/drawingml/2006/main" xmlns:r="http://schemas.openxmlformats.org/officeDocument/2006/relationships" xmlns:p="http://schemas.openxmlformats.org/presentationml/2006/main">
   <p:cSld>
     <p:spTree>
       <p:nvGrpSpPr>
@@ -12839,7 +13203,14 @@
         <p:cNvGrpSpPr/>
         <p:nvPr/>
       </p:nvGrpSpPr>
-      <p:grpSpPr/>
+      <p:grpSpPr>
+        <a:xfrm>
+          <a:off x="0" y="0"/>
+          <a:ext cx="0" cy="0"/>
+          <a:chOff x="0" y="0"/>
+          <a:chExt cx="0" cy="0"/>
+        </a:xfrm>
+      </p:grpSpPr>
       <p:sp>
         <p:nvSpPr>
           <p:cNvPr id="2" name="Rectangle 1"/>
@@ -12880,6 +13251,7 @@
           <a:lstStyle/>
           <a:p>
             <a:pPr algn="ctr"/>
+            <a:endParaRPr/>
           </a:p>
         </p:txBody>
       </p:sp>
@@ -12972,9 +13344,27 @@
                 <a:tableStyleId>{5C22544A-7EE6-4342-B048-85BDC9FD1C3A}</a:tableStyleId>
               </a:tblPr>
               <a:tblGrid>
-                <a:gridCol w="3637178"/>
-                <a:gridCol w="3637178"/>
-                <a:gridCol w="3637179"/>
+                <a:gridCol w="3637178">
+                  <a:extLst>
+                    <a:ext uri="{9D8B030D-6E8A-4147-A177-3AD203B41FA5}">
+                      <a16:colId xmlns:a16="http://schemas.microsoft.com/office/drawing/2014/main" val="20000"/>
+                    </a:ext>
+                  </a:extLst>
+                </a:gridCol>
+                <a:gridCol w="3637178">
+                  <a:extLst>
+                    <a:ext uri="{9D8B030D-6E8A-4147-A177-3AD203B41FA5}">
+                      <a16:colId xmlns:a16="http://schemas.microsoft.com/office/drawing/2014/main" val="20001"/>
+                    </a:ext>
+                  </a:extLst>
+                </a:gridCol>
+                <a:gridCol w="3637179">
+                  <a:extLst>
+                    <a:ext uri="{9D8B030D-6E8A-4147-A177-3AD203B41FA5}">
+                      <a16:colId xmlns:a16="http://schemas.microsoft.com/office/drawing/2014/main" val="20002"/>
+                    </a:ext>
+                  </a:extLst>
+                </a:gridCol>
               </a:tblGrid>
               <a:tr h="384048">
                 <a:tc>
@@ -13043,6 +13433,11 @@
                     </a:solidFill>
                   </a:tcPr>
                 </a:tc>
+                <a:extLst>
+                  <a:ext uri="{0D108BD9-81ED-4DB2-BD59-A6C34878D82A}">
+                    <a16:rowId xmlns:a16="http://schemas.microsoft.com/office/drawing/2014/main" val="10000"/>
+                  </a:ext>
+                </a:extLst>
               </a:tr>
               <a:tr h="384048">
                 <a:tc>
@@ -13111,6 +13506,11 @@
                     </a:solidFill>
                   </a:tcPr>
                 </a:tc>
+                <a:extLst>
+                  <a:ext uri="{0D108BD9-81ED-4DB2-BD59-A6C34878D82A}">
+                    <a16:rowId xmlns:a16="http://schemas.microsoft.com/office/drawing/2014/main" val="10001"/>
+                  </a:ext>
+                </a:extLst>
               </a:tr>
               <a:tr h="384048">
                 <a:tc>
@@ -13179,6 +13579,11 @@
                     </a:solidFill>
                   </a:tcPr>
                 </a:tc>
+                <a:extLst>
+                  <a:ext uri="{0D108BD9-81ED-4DB2-BD59-A6C34878D82A}">
+                    <a16:rowId xmlns:a16="http://schemas.microsoft.com/office/drawing/2014/main" val="10002"/>
+                  </a:ext>
+                </a:extLst>
               </a:tr>
               <a:tr h="384048">
                 <a:tc>
@@ -13247,6 +13652,11 @@
                     </a:solidFill>
                   </a:tcPr>
                 </a:tc>
+                <a:extLst>
+                  <a:ext uri="{0D108BD9-81ED-4DB2-BD59-A6C34878D82A}">
+                    <a16:rowId xmlns:a16="http://schemas.microsoft.com/office/drawing/2014/main" val="10003"/>
+                  </a:ext>
+                </a:extLst>
               </a:tr>
               <a:tr h="384048">
                 <a:tc>
@@ -13315,6 +13725,11 @@
                     </a:solidFill>
                   </a:tcPr>
                 </a:tc>
+                <a:extLst>
+                  <a:ext uri="{0D108BD9-81ED-4DB2-BD59-A6C34878D82A}">
+                    <a16:rowId xmlns:a16="http://schemas.microsoft.com/office/drawing/2014/main" val="10004"/>
+                  </a:ext>
+                </a:extLst>
               </a:tr>
               <a:tr h="384048">
                 <a:tc>
@@ -13383,6 +13798,11 @@
                     </a:solidFill>
                   </a:tcPr>
                 </a:tc>
+                <a:extLst>
+                  <a:ext uri="{0D108BD9-81ED-4DB2-BD59-A6C34878D82A}">
+                    <a16:rowId xmlns:a16="http://schemas.microsoft.com/office/drawing/2014/main" val="10005"/>
+                  </a:ext>
+                </a:extLst>
               </a:tr>
               <a:tr h="384048">
                 <a:tc>
@@ -13451,6 +13871,11 @@
                     </a:solidFill>
                   </a:tcPr>
                 </a:tc>
+                <a:extLst>
+                  <a:ext uri="{0D108BD9-81ED-4DB2-BD59-A6C34878D82A}">
+                    <a16:rowId xmlns:a16="http://schemas.microsoft.com/office/drawing/2014/main" val="10006"/>
+                  </a:ext>
+                </a:extLst>
               </a:tr>
             </a:tbl>
           </a:graphicData>
@@ -13465,7 +13890,7 @@
 </file>
 
 <file path=ppt/slides/slide41.xml><?xml version="1.0" encoding="utf-8"?>
-<p:sld xmlns:a="http://schemas.openxmlformats.org/drawingml/2006/main" xmlns:p="http://schemas.openxmlformats.org/presentationml/2006/main" xmlns:r="http://schemas.openxmlformats.org/officeDocument/2006/relationships">
+<p:sld xmlns:a="http://schemas.openxmlformats.org/drawingml/2006/main" xmlns:r="http://schemas.openxmlformats.org/officeDocument/2006/relationships" xmlns:p="http://schemas.openxmlformats.org/presentationml/2006/main">
   <p:cSld>
     <p:spTree>
       <p:nvGrpSpPr>
@@ -13473,7 +13898,14 @@
         <p:cNvGrpSpPr/>
         <p:nvPr/>
       </p:nvGrpSpPr>
-      <p:grpSpPr/>
+      <p:grpSpPr>
+        <a:xfrm>
+          <a:off x="0" y="0"/>
+          <a:ext cx="0" cy="0"/>
+          <a:chOff x="0" y="0"/>
+          <a:chExt cx="0" cy="0"/>
+        </a:xfrm>
+      </p:grpSpPr>
       <p:sp>
         <p:nvSpPr>
           <p:cNvPr id="2" name="Rectangle 1"/>
@@ -13514,6 +13946,7 @@
           <a:lstStyle/>
           <a:p>
             <a:pPr algn="ctr"/>
+            <a:endParaRPr/>
           </a:p>
         </p:txBody>
       </p:sp>
@@ -13580,7 +14013,7 @@
               </a:spcAft>
             </a:pPr>
             <a:r>
-              <a:rPr b="1" sz="1300">
+              <a:rPr sz="1300" b="1">
                 <a:solidFill>
                   <a:srgbClr val="14213D"/>
                 </a:solidFill>
@@ -13621,7 +14054,7 @@
               </a:spcAft>
             </a:pPr>
             <a:r>
-              <a:rPr b="1" sz="1300">
+              <a:rPr sz="1300" b="1">
                 <a:solidFill>
                   <a:srgbClr val="14213D"/>
                 </a:solidFill>
@@ -13662,7 +14095,7 @@
               </a:spcAft>
             </a:pPr>
             <a:r>
-              <a:rPr b="1" sz="1200">
+              <a:rPr sz="1200" b="1">
                 <a:solidFill>
                   <a:srgbClr val="14213D"/>
                 </a:solidFill>
@@ -13687,7 +14120,7 @@
               </a:spcAft>
             </a:pPr>
             <a:r>
-              <a:rPr b="1" sz="1200">
+              <a:rPr sz="1200" b="1">
                 <a:solidFill>
                   <a:srgbClr val="14213D"/>
                 </a:solidFill>
@@ -13712,7 +14145,7 @@
               </a:spcAft>
             </a:pPr>
             <a:r>
-              <a:rPr b="1" sz="1300">
+              <a:rPr sz="1300" b="1">
                 <a:solidFill>
                   <a:srgbClr val="14213D"/>
                 </a:solidFill>
@@ -13741,7 +14174,7 @@
 </file>
 
 <file path=ppt/slides/slide42.xml><?xml version="1.0" encoding="utf-8"?>
-<p:sld xmlns:a="http://schemas.openxmlformats.org/drawingml/2006/main" xmlns:p="http://schemas.openxmlformats.org/presentationml/2006/main" xmlns:r="http://schemas.openxmlformats.org/officeDocument/2006/relationships">
+<p:sld xmlns:a="http://schemas.openxmlformats.org/drawingml/2006/main" xmlns:r="http://schemas.openxmlformats.org/officeDocument/2006/relationships" xmlns:p="http://schemas.openxmlformats.org/presentationml/2006/main">
   <p:cSld>
     <p:spTree>
       <p:nvGrpSpPr>
@@ -13749,7 +14182,14 @@
         <p:cNvGrpSpPr/>
         <p:nvPr/>
       </p:nvGrpSpPr>
-      <p:grpSpPr/>
+      <p:grpSpPr>
+        <a:xfrm>
+          <a:off x="0" y="0"/>
+          <a:ext cx="0" cy="0"/>
+          <a:chOff x="0" y="0"/>
+          <a:chExt cx="0" cy="0"/>
+        </a:xfrm>
+      </p:grpSpPr>
       <p:sp>
         <p:nvSpPr>
           <p:cNvPr id="2" name="Rectangle 1"/>
@@ -13790,6 +14230,7 @@
           <a:lstStyle/>
           <a:p>
             <a:pPr algn="ctr"/>
+            <a:endParaRPr/>
           </a:p>
         </p:txBody>
       </p:sp>
@@ -13856,7 +14297,7 @@
               </a:spcAft>
             </a:pPr>
             <a:r>
-              <a:rPr b="1" sz="1200">
+              <a:rPr sz="1200" b="1">
                 <a:solidFill>
                   <a:srgbClr val="14213D"/>
                 </a:solidFill>
@@ -13897,7 +14338,7 @@
               </a:spcAft>
             </a:pPr>
             <a:r>
-              <a:rPr b="1" sz="1200">
+              <a:rPr sz="1200" b="1">
                 <a:solidFill>
                   <a:srgbClr val="14213D"/>
                 </a:solidFill>
@@ -13922,7 +14363,7 @@
               </a:spcAft>
             </a:pPr>
             <a:r>
-              <a:rPr b="1" sz="1200">
+              <a:rPr sz="1200" b="1">
                 <a:solidFill>
                   <a:srgbClr val="14213D"/>
                 </a:solidFill>
@@ -13947,7 +14388,7 @@
               </a:spcAft>
             </a:pPr>
             <a:r>
-              <a:rPr b="1" sz="1200">
+              <a:rPr sz="1200" b="1">
                 <a:solidFill>
                   <a:srgbClr val="14213D"/>
                 </a:solidFill>
@@ -14021,7 +14462,7 @@
 </file>
 
 <file path=ppt/slides/slide43.xml><?xml version="1.0" encoding="utf-8"?>
-<p:sld xmlns:a="http://schemas.openxmlformats.org/drawingml/2006/main" xmlns:p="http://schemas.openxmlformats.org/presentationml/2006/main" xmlns:r="http://schemas.openxmlformats.org/officeDocument/2006/relationships">
+<p:sld xmlns:a="http://schemas.openxmlformats.org/drawingml/2006/main" xmlns:r="http://schemas.openxmlformats.org/officeDocument/2006/relationships" xmlns:p="http://schemas.openxmlformats.org/presentationml/2006/main">
   <p:cSld>
     <p:spTree>
       <p:nvGrpSpPr>
@@ -14029,7 +14470,14 @@
         <p:cNvGrpSpPr/>
         <p:nvPr/>
       </p:nvGrpSpPr>
-      <p:grpSpPr/>
+      <p:grpSpPr>
+        <a:xfrm>
+          <a:off x="0" y="0"/>
+          <a:ext cx="0" cy="0"/>
+          <a:chOff x="0" y="0"/>
+          <a:chExt cx="0" cy="0"/>
+        </a:xfrm>
+      </p:grpSpPr>
       <p:sp>
         <p:nvSpPr>
           <p:cNvPr id="2" name="Rectangle 1"/>
@@ -14070,6 +14518,7 @@
           <a:lstStyle/>
           <a:p>
             <a:pPr algn="ctr"/>
+            <a:endParaRPr/>
           </a:p>
         </p:txBody>
       </p:sp>
@@ -14113,6 +14562,7 @@
           <a:lstStyle/>
           <a:p>
             <a:pPr algn="ctr"/>
+            <a:endParaRPr/>
           </a:p>
         </p:txBody>
       </p:sp>
@@ -14230,7 +14680,7 @@
 </file>
 
 <file path=ppt/slides/slide44.xml><?xml version="1.0" encoding="utf-8"?>
-<p:sld xmlns:a="http://schemas.openxmlformats.org/drawingml/2006/main" xmlns:p="http://schemas.openxmlformats.org/presentationml/2006/main" xmlns:r="http://schemas.openxmlformats.org/officeDocument/2006/relationships">
+<p:sld xmlns:a="http://schemas.openxmlformats.org/drawingml/2006/main" xmlns:r="http://schemas.openxmlformats.org/officeDocument/2006/relationships" xmlns:p="http://schemas.openxmlformats.org/presentationml/2006/main">
   <p:cSld>
     <p:spTree>
       <p:nvGrpSpPr>
@@ -14238,7 +14688,14 @@
         <p:cNvGrpSpPr/>
         <p:nvPr/>
       </p:nvGrpSpPr>
-      <p:grpSpPr/>
+      <p:grpSpPr>
+        <a:xfrm>
+          <a:off x="0" y="0"/>
+          <a:ext cx="0" cy="0"/>
+          <a:chOff x="0" y="0"/>
+          <a:chExt cx="0" cy="0"/>
+        </a:xfrm>
+      </p:grpSpPr>
       <p:sp>
         <p:nvSpPr>
           <p:cNvPr id="2" name="Rectangle 1"/>
@@ -14279,6 +14736,7 @@
           <a:lstStyle/>
           <a:p>
             <a:pPr algn="ctr"/>
+            <a:endParaRPr/>
           </a:p>
         </p:txBody>
       </p:sp>
@@ -14345,7 +14803,7 @@
               </a:spcAft>
             </a:pPr>
             <a:r>
-              <a:rPr b="1" sz="1300">
+              <a:rPr sz="1300" b="1">
                 <a:solidFill>
                   <a:srgbClr val="14213D"/>
                 </a:solidFill>
@@ -14370,7 +14828,7 @@
               </a:spcAft>
             </a:pPr>
             <a:r>
-              <a:rPr b="1" sz="1300">
+              <a:rPr sz="1300" b="1">
                 <a:solidFill>
                   <a:srgbClr val="14213D"/>
                 </a:solidFill>
@@ -14395,7 +14853,7 @@
               </a:spcAft>
             </a:pPr>
             <a:r>
-              <a:rPr b="1" sz="1300">
+              <a:rPr sz="1300" b="1">
                 <a:solidFill>
                   <a:srgbClr val="14213D"/>
                 </a:solidFill>
@@ -14420,7 +14878,7 @@
               </a:spcAft>
             </a:pPr>
             <a:r>
-              <a:rPr b="1" sz="1300">
+              <a:rPr sz="1300" b="1">
                 <a:solidFill>
                   <a:srgbClr val="14213D"/>
                 </a:solidFill>
@@ -14445,7 +14903,7 @@
               </a:spcAft>
             </a:pPr>
             <a:r>
-              <a:rPr b="1" sz="1300">
+              <a:rPr sz="1300" b="1">
                 <a:solidFill>
                   <a:srgbClr val="14213D"/>
                 </a:solidFill>
@@ -14470,7 +14928,7 @@
               </a:spcAft>
             </a:pPr>
             <a:r>
-              <a:rPr b="1" sz="1300">
+              <a:rPr sz="1300" b="1">
                 <a:solidFill>
                   <a:srgbClr val="14213D"/>
                 </a:solidFill>
@@ -14518,7 +14976,7 @@
               </a:spcAft>
             </a:pPr>
             <a:r>
-              <a:rPr b="1" sz="1300">
+              <a:rPr sz="1300" b="1">
                 <a:solidFill>
                   <a:srgbClr val="14213D"/>
                 </a:solidFill>
@@ -14543,7 +15001,7 @@
               </a:spcAft>
             </a:pPr>
             <a:r>
-              <a:rPr b="1" sz="1300">
+              <a:rPr sz="1300" b="1">
                 <a:solidFill>
                   <a:srgbClr val="14213D"/>
                 </a:solidFill>
@@ -14568,7 +15026,7 @@
               </a:spcAft>
             </a:pPr>
             <a:r>
-              <a:rPr b="1" sz="1300">
+              <a:rPr sz="1300" b="1">
                 <a:solidFill>
                   <a:srgbClr val="14213D"/>
                 </a:solidFill>
@@ -14593,7 +15051,7 @@
               </a:spcAft>
             </a:pPr>
             <a:r>
-              <a:rPr b="1" sz="1300">
+              <a:rPr sz="1300" b="1">
                 <a:solidFill>
                   <a:srgbClr val="14213D"/>
                 </a:solidFill>
@@ -14618,7 +15076,7 @@
               </a:spcAft>
             </a:pPr>
             <a:r>
-              <a:rPr b="1" sz="1300">
+              <a:rPr sz="1300" b="1">
                 <a:solidFill>
                   <a:srgbClr val="14213D"/>
                 </a:solidFill>
@@ -14643,7 +15101,7 @@
               </a:spcAft>
             </a:pPr>
             <a:r>
-              <a:rPr b="1" sz="1300">
+              <a:rPr sz="1300" b="1">
                 <a:solidFill>
                   <a:srgbClr val="14213D"/>
                 </a:solidFill>
@@ -14672,7 +15130,7 @@
 </file>
 
 <file path=ppt/slides/slide45.xml><?xml version="1.0" encoding="utf-8"?>
-<p:sld xmlns:a="http://schemas.openxmlformats.org/drawingml/2006/main" xmlns:p="http://schemas.openxmlformats.org/presentationml/2006/main" xmlns:r="http://schemas.openxmlformats.org/officeDocument/2006/relationships">
+<p:sld xmlns:a="http://schemas.openxmlformats.org/drawingml/2006/main" xmlns:r="http://schemas.openxmlformats.org/officeDocument/2006/relationships" xmlns:p="http://schemas.openxmlformats.org/presentationml/2006/main">
   <p:cSld>
     <p:spTree>
       <p:nvGrpSpPr>
@@ -14680,7 +15138,14 @@
         <p:cNvGrpSpPr/>
         <p:nvPr/>
       </p:nvGrpSpPr>
-      <p:grpSpPr/>
+      <p:grpSpPr>
+        <a:xfrm>
+          <a:off x="0" y="0"/>
+          <a:ext cx="0" cy="0"/>
+          <a:chOff x="0" y="0"/>
+          <a:chExt cx="0" cy="0"/>
+        </a:xfrm>
+      </p:grpSpPr>
       <p:sp>
         <p:nvSpPr>
           <p:cNvPr id="2" name="Rectangle 1"/>
@@ -14721,6 +15186,7 @@
           <a:lstStyle/>
           <a:p>
             <a:pPr algn="ctr"/>
+            <a:endParaRPr/>
           </a:p>
         </p:txBody>
       </p:sp>
@@ -14813,8 +15279,20 @@
                 <a:tableStyleId>{5C22544A-7EE6-4342-B048-85BDC9FD1C3A}</a:tableStyleId>
               </a:tblPr>
               <a:tblGrid>
-                <a:gridCol w="5455767"/>
-                <a:gridCol w="5455768"/>
+                <a:gridCol w="5455767">
+                  <a:extLst>
+                    <a:ext uri="{9D8B030D-6E8A-4147-A177-3AD203B41FA5}">
+                      <a16:colId xmlns:a16="http://schemas.microsoft.com/office/drawing/2014/main" val="20000"/>
+                    </a:ext>
+                  </a:extLst>
+                </a:gridCol>
+                <a:gridCol w="5455768">
+                  <a:extLst>
+                    <a:ext uri="{9D8B030D-6E8A-4147-A177-3AD203B41FA5}">
+                      <a16:colId xmlns:a16="http://schemas.microsoft.com/office/drawing/2014/main" val="20001"/>
+                    </a:ext>
+                  </a:extLst>
+                </a:gridCol>
               </a:tblGrid>
               <a:tr h="384048">
                 <a:tc>
@@ -14861,6 +15339,11 @@
                     </a:solidFill>
                   </a:tcPr>
                 </a:tc>
+                <a:extLst>
+                  <a:ext uri="{0D108BD9-81ED-4DB2-BD59-A6C34878D82A}">
+                    <a16:rowId xmlns:a16="http://schemas.microsoft.com/office/drawing/2014/main" val="10000"/>
+                  </a:ext>
+                </a:extLst>
               </a:tr>
               <a:tr h="384048">
                 <a:tc>
@@ -14907,6 +15390,11 @@
                     </a:solidFill>
                   </a:tcPr>
                 </a:tc>
+                <a:extLst>
+                  <a:ext uri="{0D108BD9-81ED-4DB2-BD59-A6C34878D82A}">
+                    <a16:rowId xmlns:a16="http://schemas.microsoft.com/office/drawing/2014/main" val="10001"/>
+                  </a:ext>
+                </a:extLst>
               </a:tr>
               <a:tr h="384048">
                 <a:tc>
@@ -14953,6 +15441,11 @@
                     </a:solidFill>
                   </a:tcPr>
                 </a:tc>
+                <a:extLst>
+                  <a:ext uri="{0D108BD9-81ED-4DB2-BD59-A6C34878D82A}">
+                    <a16:rowId xmlns:a16="http://schemas.microsoft.com/office/drawing/2014/main" val="10002"/>
+                  </a:ext>
+                </a:extLst>
               </a:tr>
               <a:tr h="384048">
                 <a:tc>
@@ -14999,6 +15492,11 @@
                     </a:solidFill>
                   </a:tcPr>
                 </a:tc>
+                <a:extLst>
+                  <a:ext uri="{0D108BD9-81ED-4DB2-BD59-A6C34878D82A}">
+                    <a16:rowId xmlns:a16="http://schemas.microsoft.com/office/drawing/2014/main" val="10003"/>
+                  </a:ext>
+                </a:extLst>
               </a:tr>
               <a:tr h="384048">
                 <a:tc>
@@ -15045,6 +15543,11 @@
                     </a:solidFill>
                   </a:tcPr>
                 </a:tc>
+                <a:extLst>
+                  <a:ext uri="{0D108BD9-81ED-4DB2-BD59-A6C34878D82A}">
+                    <a16:rowId xmlns:a16="http://schemas.microsoft.com/office/drawing/2014/main" val="10004"/>
+                  </a:ext>
+                </a:extLst>
               </a:tr>
               <a:tr h="384048">
                 <a:tc>
@@ -15091,6 +15594,11 @@
                     </a:solidFill>
                   </a:tcPr>
                 </a:tc>
+                <a:extLst>
+                  <a:ext uri="{0D108BD9-81ED-4DB2-BD59-A6C34878D82A}">
+                    <a16:rowId xmlns:a16="http://schemas.microsoft.com/office/drawing/2014/main" val="10005"/>
+                  </a:ext>
+                </a:extLst>
               </a:tr>
               <a:tr h="384048">
                 <a:tc>
@@ -15137,6 +15645,11 @@
                     </a:solidFill>
                   </a:tcPr>
                 </a:tc>
+                <a:extLst>
+                  <a:ext uri="{0D108BD9-81ED-4DB2-BD59-A6C34878D82A}">
+                    <a16:rowId xmlns:a16="http://schemas.microsoft.com/office/drawing/2014/main" val="10006"/>
+                  </a:ext>
+                </a:extLst>
               </a:tr>
               <a:tr h="384048">
                 <a:tc>
@@ -15183,6 +15696,11 @@
                     </a:solidFill>
                   </a:tcPr>
                 </a:tc>
+                <a:extLst>
+                  <a:ext uri="{0D108BD9-81ED-4DB2-BD59-A6C34878D82A}">
+                    <a16:rowId xmlns:a16="http://schemas.microsoft.com/office/drawing/2014/main" val="10007"/>
+                  </a:ext>
+                </a:extLst>
               </a:tr>
             </a:tbl>
           </a:graphicData>
@@ -15197,7 +15715,7 @@
 </file>
 
 <file path=ppt/slides/slide46.xml><?xml version="1.0" encoding="utf-8"?>
-<p:sld xmlns:a="http://schemas.openxmlformats.org/drawingml/2006/main" xmlns:p="http://schemas.openxmlformats.org/presentationml/2006/main" xmlns:r="http://schemas.openxmlformats.org/officeDocument/2006/relationships">
+<p:sld xmlns:a="http://schemas.openxmlformats.org/drawingml/2006/main" xmlns:r="http://schemas.openxmlformats.org/officeDocument/2006/relationships" xmlns:p="http://schemas.openxmlformats.org/presentationml/2006/main">
   <p:cSld>
     <p:spTree>
       <p:nvGrpSpPr>
@@ -15205,7 +15723,14 @@
         <p:cNvGrpSpPr/>
         <p:nvPr/>
       </p:nvGrpSpPr>
-      <p:grpSpPr/>
+      <p:grpSpPr>
+        <a:xfrm>
+          <a:off x="0" y="0"/>
+          <a:ext cx="0" cy="0"/>
+          <a:chOff x="0" y="0"/>
+          <a:chExt cx="0" cy="0"/>
+        </a:xfrm>
+      </p:grpSpPr>
       <p:sp>
         <p:nvSpPr>
           <p:cNvPr id="2" name="Rectangle 1"/>
@@ -15246,6 +15771,7 @@
           <a:lstStyle/>
           <a:p>
             <a:pPr algn="ctr"/>
+            <a:endParaRPr/>
           </a:p>
         </p:txBody>
       </p:sp>
@@ -15312,7 +15838,7 @@
               </a:spcAft>
             </a:pPr>
             <a:r>
-              <a:rPr b="1" sz="1300">
+              <a:rPr sz="1300" b="1">
                 <a:solidFill>
                   <a:srgbClr val="14213D"/>
                 </a:solidFill>
@@ -15369,7 +15895,7 @@
               </a:spcAft>
             </a:pPr>
             <a:r>
-              <a:rPr b="1" sz="1300">
+              <a:rPr sz="1300" b="1">
                 <a:solidFill>
                   <a:srgbClr val="14213D"/>
                 </a:solidFill>
@@ -15394,7 +15920,7 @@
               </a:spcAft>
             </a:pPr>
             <a:r>
-              <a:rPr b="1" sz="1300">
+              <a:rPr sz="1300" b="1">
                 <a:solidFill>
                   <a:srgbClr val="14213D"/>
                 </a:solidFill>
@@ -15419,7 +15945,7 @@
               </a:spcAft>
             </a:pPr>
             <a:r>
-              <a:rPr b="1" sz="1300">
+              <a:rPr sz="1300" b="1">
                 <a:solidFill>
                   <a:srgbClr val="14213D"/>
                 </a:solidFill>
@@ -15464,7 +15990,7 @@
 </file>
 
 <file path=ppt/slides/slide47.xml><?xml version="1.0" encoding="utf-8"?>
-<p:sld xmlns:a="http://schemas.openxmlformats.org/drawingml/2006/main" xmlns:p="http://schemas.openxmlformats.org/presentationml/2006/main" xmlns:r="http://schemas.openxmlformats.org/officeDocument/2006/relationships">
+<p:sld xmlns:a="http://schemas.openxmlformats.org/drawingml/2006/main" xmlns:r="http://schemas.openxmlformats.org/officeDocument/2006/relationships" xmlns:p="http://schemas.openxmlformats.org/presentationml/2006/main">
   <p:cSld>
     <p:spTree>
       <p:nvGrpSpPr>
@@ -15472,7 +15998,14 @@
         <p:cNvGrpSpPr/>
         <p:nvPr/>
       </p:nvGrpSpPr>
-      <p:grpSpPr/>
+      <p:grpSpPr>
+        <a:xfrm>
+          <a:off x="0" y="0"/>
+          <a:ext cx="0" cy="0"/>
+          <a:chOff x="0" y="0"/>
+          <a:chExt cx="0" cy="0"/>
+        </a:xfrm>
+      </p:grpSpPr>
       <p:sp>
         <p:nvSpPr>
           <p:cNvPr id="2" name="Rectangle 1"/>
@@ -15513,6 +16046,7 @@
           <a:lstStyle/>
           <a:p>
             <a:pPr algn="ctr"/>
+            <a:endParaRPr/>
           </a:p>
         </p:txBody>
       </p:sp>
@@ -15556,6 +16090,7 @@
           <a:lstStyle/>
           <a:p>
             <a:pPr algn="ctr"/>
+            <a:endParaRPr/>
           </a:p>
         </p:txBody>
       </p:sp>
@@ -15639,7 +16174,7 @@
 </file>
 
 <file path=ppt/slides/slide5.xml><?xml version="1.0" encoding="utf-8"?>
-<p:sld xmlns:a="http://schemas.openxmlformats.org/drawingml/2006/main" xmlns:p="http://schemas.openxmlformats.org/presentationml/2006/main" xmlns:r="http://schemas.openxmlformats.org/officeDocument/2006/relationships">
+<p:sld xmlns:a="http://schemas.openxmlformats.org/drawingml/2006/main" xmlns:r="http://schemas.openxmlformats.org/officeDocument/2006/relationships" xmlns:p="http://schemas.openxmlformats.org/presentationml/2006/main">
   <p:cSld>
     <p:spTree>
       <p:nvGrpSpPr>
@@ -15647,7 +16182,14 @@
         <p:cNvGrpSpPr/>
         <p:nvPr/>
       </p:nvGrpSpPr>
-      <p:grpSpPr/>
+      <p:grpSpPr>
+        <a:xfrm>
+          <a:off x="0" y="0"/>
+          <a:ext cx="0" cy="0"/>
+          <a:chOff x="0" y="0"/>
+          <a:chExt cx="0" cy="0"/>
+        </a:xfrm>
+      </p:grpSpPr>
       <p:sp>
         <p:nvSpPr>
           <p:cNvPr id="2" name="Rectangle 1"/>
@@ -15688,6 +16230,7 @@
           <a:lstStyle/>
           <a:p>
             <a:pPr algn="ctr"/>
+            <a:endParaRPr/>
           </a:p>
         </p:txBody>
       </p:sp>
@@ -15754,7 +16297,7 @@
               </a:spcAft>
             </a:pPr>
             <a:r>
-              <a:rPr b="1" sz="1400">
+              <a:rPr sz="1400" b="1">
                 <a:solidFill>
                   <a:srgbClr val="14213D"/>
                 </a:solidFill>
@@ -15779,7 +16322,7 @@
               </a:spcAft>
             </a:pPr>
             <a:r>
-              <a:rPr b="1" sz="1400">
+              <a:rPr sz="1400" b="1">
                 <a:solidFill>
                   <a:srgbClr val="14213D"/>
                 </a:solidFill>
@@ -15804,7 +16347,7 @@
               </a:spcAft>
             </a:pPr>
             <a:r>
-              <a:rPr b="1" sz="1400">
+              <a:rPr sz="1400" b="1">
                 <a:solidFill>
                   <a:srgbClr val="14213D"/>
                 </a:solidFill>
@@ -15829,7 +16372,7 @@
               </a:spcAft>
             </a:pPr>
             <a:r>
-              <a:rPr b="1" sz="1400">
+              <a:rPr sz="1400" b="1">
                 <a:solidFill>
                   <a:srgbClr val="14213D"/>
                 </a:solidFill>
@@ -15858,7 +16401,7 @@
 </file>
 
 <file path=ppt/slides/slide6.xml><?xml version="1.0" encoding="utf-8"?>
-<p:sld xmlns:a="http://schemas.openxmlformats.org/drawingml/2006/main" xmlns:p="http://schemas.openxmlformats.org/presentationml/2006/main" xmlns:r="http://schemas.openxmlformats.org/officeDocument/2006/relationships">
+<p:sld xmlns:a="http://schemas.openxmlformats.org/drawingml/2006/main" xmlns:r="http://schemas.openxmlformats.org/officeDocument/2006/relationships" xmlns:p="http://schemas.openxmlformats.org/presentationml/2006/main">
   <p:cSld>
     <p:spTree>
       <p:nvGrpSpPr>
@@ -15866,7 +16409,14 @@
         <p:cNvGrpSpPr/>
         <p:nvPr/>
       </p:nvGrpSpPr>
-      <p:grpSpPr/>
+      <p:grpSpPr>
+        <a:xfrm>
+          <a:off x="0" y="0"/>
+          <a:ext cx="0" cy="0"/>
+          <a:chOff x="0" y="0"/>
+          <a:chExt cx="0" cy="0"/>
+        </a:xfrm>
+      </p:grpSpPr>
       <p:sp>
         <p:nvSpPr>
           <p:cNvPr id="2" name="Rectangle 1"/>
@@ -15907,6 +16457,7 @@
           <a:lstStyle/>
           <a:p>
             <a:pPr algn="ctr"/>
+            <a:endParaRPr/>
           </a:p>
         </p:txBody>
       </p:sp>
@@ -15950,6 +16501,7 @@
           <a:lstStyle/>
           <a:p>
             <a:pPr algn="ctr"/>
+            <a:endParaRPr/>
           </a:p>
         </p:txBody>
       </p:sp>
@@ -16067,7 +16619,7 @@
 </file>
 
 <file path=ppt/slides/slide7.xml><?xml version="1.0" encoding="utf-8"?>
-<p:sld xmlns:a="http://schemas.openxmlformats.org/drawingml/2006/main" xmlns:p="http://schemas.openxmlformats.org/presentationml/2006/main" xmlns:r="http://schemas.openxmlformats.org/officeDocument/2006/relationships">
+<p:sld xmlns:a="http://schemas.openxmlformats.org/drawingml/2006/main" xmlns:r="http://schemas.openxmlformats.org/officeDocument/2006/relationships" xmlns:p="http://schemas.openxmlformats.org/presentationml/2006/main">
   <p:cSld>
     <p:spTree>
       <p:nvGrpSpPr>
@@ -16075,7 +16627,14 @@
         <p:cNvGrpSpPr/>
         <p:nvPr/>
       </p:nvGrpSpPr>
-      <p:grpSpPr/>
+      <p:grpSpPr>
+        <a:xfrm>
+          <a:off x="0" y="0"/>
+          <a:ext cx="0" cy="0"/>
+          <a:chOff x="0" y="0"/>
+          <a:chExt cx="0" cy="0"/>
+        </a:xfrm>
+      </p:grpSpPr>
       <p:sp>
         <p:nvSpPr>
           <p:cNvPr id="2" name="Rectangle 1"/>
@@ -16116,6 +16675,7 @@
           <a:lstStyle/>
           <a:p>
             <a:pPr algn="ctr"/>
+            <a:endParaRPr/>
           </a:p>
         </p:txBody>
       </p:sp>
@@ -16163,7 +16723,7 @@
         <p:spPr>
           <a:xfrm>
             <a:off x="502920" y="841248"/>
-            <a:ext cx="11185855" cy="411480"/>
+            <a:ext cx="11185855" cy="292388"/>
           </a:xfrm>
           <a:prstGeom prst="rect">
             <a:avLst/>
@@ -16178,13 +16738,85 @@
           <a:p>
             <a:pPr algn="l"/>
             <a:r>
-              <a:rPr sz="1300" b="0">
-                <a:solidFill>
-                  <a:srgbClr val="454F5B"/>
-                </a:solidFill>
-                <a:latin typeface="Segoe UI"/>
-              </a:rPr>
-              <a:t>Los números en rojo se corresponden con el paso a paso de las siguientes láminas.</a:t>
+              <a:rPr sz="1300" b="0" dirty="0">
+                <a:solidFill>
+                  <a:srgbClr val="454F5B"/>
+                </a:solidFill>
+                <a:latin typeface="Segoe UI"/>
+              </a:rPr>
+              <a:t>Los </a:t>
+            </a:r>
+            <a:r>
+              <a:rPr sz="1300" b="0" dirty="0" err="1">
+                <a:solidFill>
+                  <a:srgbClr val="454F5B"/>
+                </a:solidFill>
+                <a:latin typeface="Segoe UI"/>
+              </a:rPr>
+              <a:t>números</a:t>
+            </a:r>
+            <a:r>
+              <a:rPr sz="1300" b="0" dirty="0">
+                <a:solidFill>
+                  <a:srgbClr val="454F5B"/>
+                </a:solidFill>
+                <a:latin typeface="Segoe UI"/>
+              </a:rPr>
+              <a:t> se </a:t>
+            </a:r>
+            <a:r>
+              <a:rPr sz="1300" b="0" dirty="0" err="1">
+                <a:solidFill>
+                  <a:srgbClr val="454F5B"/>
+                </a:solidFill>
+                <a:latin typeface="Segoe UI"/>
+              </a:rPr>
+              <a:t>corresponden</a:t>
+            </a:r>
+            <a:r>
+              <a:rPr sz="1300" b="0" dirty="0">
+                <a:solidFill>
+                  <a:srgbClr val="454F5B"/>
+                </a:solidFill>
+                <a:latin typeface="Segoe UI"/>
+              </a:rPr>
+              <a:t> con el paso a paso de las </a:t>
+            </a:r>
+            <a:r>
+              <a:rPr sz="1300" b="0" dirty="0" err="1">
+                <a:solidFill>
+                  <a:srgbClr val="454F5B"/>
+                </a:solidFill>
+                <a:latin typeface="Segoe UI"/>
+              </a:rPr>
+              <a:t>siguientes</a:t>
+            </a:r>
+            <a:r>
+              <a:rPr sz="1300" b="0" dirty="0">
+                <a:solidFill>
+                  <a:srgbClr val="454F5B"/>
+                </a:solidFill>
+                <a:latin typeface="Segoe UI"/>
+              </a:rPr>
+              <a:t> </a:t>
+            </a:r>
+            <a:r>
+              <a:rPr sz="1300" b="0" dirty="0" err="1">
+                <a:solidFill>
+                  <a:srgbClr val="454F5B"/>
+                </a:solidFill>
+                <a:latin typeface="Segoe UI"/>
+              </a:rPr>
+              <a:t>láminas</a:t>
+            </a:r>
+            <a:r>
+              <a:rPr sz="1300" b="0" dirty="0">
+                <a:solidFill>
+                  <a:srgbClr val="454F5B"/>
+                </a:solidFill>
+                <a:latin typeface="Segoe UI"/>
+              </a:rPr>
+              <a:t>.</a:t>
             </a:r>
           </a:p>
         </p:txBody>
@@ -16227,7 +16859,7 @@
 </file>
 
 <file path=ppt/slides/slide8.xml><?xml version="1.0" encoding="utf-8"?>
-<p:sld xmlns:a="http://schemas.openxmlformats.org/drawingml/2006/main" xmlns:p="http://schemas.openxmlformats.org/presentationml/2006/main" xmlns:r="http://schemas.openxmlformats.org/officeDocument/2006/relationships">
+<p:sld xmlns:a="http://schemas.openxmlformats.org/drawingml/2006/main" xmlns:r="http://schemas.openxmlformats.org/officeDocument/2006/relationships" xmlns:p="http://schemas.openxmlformats.org/presentationml/2006/main">
   <p:cSld>
     <p:spTree>
       <p:nvGrpSpPr>
@@ -16235,7 +16867,14 @@
         <p:cNvGrpSpPr/>
         <p:nvPr/>
       </p:nvGrpSpPr>
-      <p:grpSpPr/>
+      <p:grpSpPr>
+        <a:xfrm>
+          <a:off x="0" y="0"/>
+          <a:ext cx="0" cy="0"/>
+          <a:chOff x="0" y="0"/>
+          <a:chExt cx="0" cy="0"/>
+        </a:xfrm>
+      </p:grpSpPr>
       <p:sp>
         <p:nvSpPr>
           <p:cNvPr id="2" name="Rectangle 1"/>
@@ -16276,6 +16915,7 @@
           <a:lstStyle/>
           <a:p>
             <a:pPr algn="ctr"/>
+            <a:endParaRPr/>
           </a:p>
         </p:txBody>
       </p:sp>
@@ -16377,7 +17017,7 @@
               </a:spcAft>
             </a:pPr>
             <a:r>
-              <a:rPr b="1" sz="1200">
+              <a:rPr sz="1200" b="1">
                 <a:solidFill>
                   <a:srgbClr val="14213D"/>
                 </a:solidFill>
@@ -16402,7 +17042,7 @@
               </a:spcAft>
             </a:pPr>
             <a:r>
-              <a:rPr b="1" sz="1200">
+              <a:rPr sz="1200" b="1">
                 <a:solidFill>
                   <a:srgbClr val="14213D"/>
                 </a:solidFill>
@@ -16427,7 +17067,7 @@
               </a:spcAft>
             </a:pPr>
             <a:r>
-              <a:rPr b="1" sz="1200">
+              <a:rPr sz="1200" b="1">
                 <a:solidFill>
                   <a:srgbClr val="14213D"/>
                 </a:solidFill>
@@ -16452,7 +17092,7 @@
               </a:spcAft>
             </a:pPr>
             <a:r>
-              <a:rPr b="1" sz="1200">
+              <a:rPr sz="1200" b="1">
                 <a:solidFill>
                   <a:srgbClr val="14213D"/>
                 </a:solidFill>
@@ -16477,7 +17117,7 @@
               </a:spcAft>
             </a:pPr>
             <a:r>
-              <a:rPr b="1" sz="1200">
+              <a:rPr sz="1200" b="1">
                 <a:solidFill>
                   <a:srgbClr val="14213D"/>
                 </a:solidFill>
@@ -16535,7 +17175,7 @@
 </file>
 
 <file path=ppt/slides/slide9.xml><?xml version="1.0" encoding="utf-8"?>
-<p:sld xmlns:a="http://schemas.openxmlformats.org/drawingml/2006/main" xmlns:p="http://schemas.openxmlformats.org/presentationml/2006/main" xmlns:r="http://schemas.openxmlformats.org/officeDocument/2006/relationships">
+<p:sld xmlns:a="http://schemas.openxmlformats.org/drawingml/2006/main" xmlns:r="http://schemas.openxmlformats.org/officeDocument/2006/relationships" xmlns:p="http://schemas.openxmlformats.org/presentationml/2006/main">
   <p:cSld>
     <p:spTree>
       <p:nvGrpSpPr>
@@ -16543,7 +17183,14 @@
         <p:cNvGrpSpPr/>
         <p:nvPr/>
       </p:nvGrpSpPr>
-      <p:grpSpPr/>
+      <p:grpSpPr>
+        <a:xfrm>
+          <a:off x="0" y="0"/>
+          <a:ext cx="0" cy="0"/>
+          <a:chOff x="0" y="0"/>
+          <a:chExt cx="0" cy="0"/>
+        </a:xfrm>
+      </p:grpSpPr>
       <p:sp>
         <p:nvSpPr>
           <p:cNvPr id="2" name="Rectangle 1"/>
@@ -16584,6 +17231,7 @@
           <a:lstStyle/>
           <a:p>
             <a:pPr algn="ctr"/>
+            <a:endParaRPr/>
           </a:p>
         </p:txBody>
       </p:sp>
@@ -16685,7 +17333,7 @@
               </a:spcAft>
             </a:pPr>
             <a:r>
-              <a:rPr b="1" sz="1300">
+              <a:rPr sz="1300" b="1">
                 <a:solidFill>
                   <a:srgbClr val="14213D"/>
                 </a:solidFill>
@@ -16710,7 +17358,7 @@
               </a:spcAft>
             </a:pPr>
             <a:r>
-              <a:rPr b="1" sz="1300">
+              <a:rPr sz="1300" b="1">
                 <a:solidFill>
                   <a:srgbClr val="14213D"/>
                 </a:solidFill>
@@ -16735,7 +17383,7 @@
               </a:spcAft>
             </a:pPr>
             <a:r>
-              <a:rPr b="1" sz="1300">
+              <a:rPr sz="1300" b="1">
                 <a:solidFill>
                   <a:srgbClr val="14213D"/>
                 </a:solidFill>
@@ -16776,7 +17424,7 @@
               </a:spcAft>
             </a:pPr>
             <a:r>
-              <a:rPr b="1" sz="1300">
+              <a:rPr sz="1300" b="1">
                 <a:solidFill>
                   <a:srgbClr val="14213D"/>
                 </a:solidFill>
@@ -16801,7 +17449,7 @@
               </a:spcAft>
             </a:pPr>
             <a:r>
-              <a:rPr b="1" sz="1300">
+              <a:rPr sz="1300" b="1">
                 <a:solidFill>
                   <a:srgbClr val="14213D"/>
                 </a:solidFill>

</xml_diff>

<commit_message>
Docs: reflejar el nuevo indicador de paises con campos detectados
Suma el bullet del resumen por pais (con cantidad) tanto en la guia de
uso (solapa Campos detectados) como en el pptx (slide de IDs Dinamicos),
para que coincidan con el cambio de interface/ids_dinamicos_ui.py.
</commit_message>
<xml_diff>
--- a/Osocio_Form_Automation_Guia.pptx
+++ b/Osocio_Form_Automation_Guia.pptx
@@ -4523,6 +4523,31 @@
                 <a:latin typeface="Segoe UI"/>
               </a:rPr>
               <a:t>Muestra los campos nuevos que la automatización encontró durante las corridas, por país, con su label, ID real, tipo y si es requerido.</a:t>
+            </a:r>
+          </a:p>
+          <a:p>
+            <a:pPr>
+              <a:spcAft>
+                <a:spcPts val="700"/>
+              </a:spcAft>
+            </a:pPr>
+            <a:r>
+              <a:rPr sz="1200" b="1">
+                <a:solidFill>
+                  <a:srgbClr val="14213D"/>
+                </a:solidFill>
+                <a:latin typeface="Segoe UI"/>
+              </a:rPr>
+              <a:t>Resumen por país: </a:t>
+            </a:r>
+            <a:r>
+              <a:rPr sz="1200">
+                <a:solidFill>
+                  <a:srgbClr val="454F5B"/>
+                </a:solidFill>
+                <a:latin typeface="Segoe UI"/>
+              </a:rPr>
+              <a:t>debajo del selector de país aparece un renglón en verde que lista, sin tener que ir uno por uno, en qué mercados hay campos nuevos pendientes (con la cantidad); si no hay ninguno, avisa en gris que no hay pendientes.</a:t>
             </a:r>
           </a:p>
           <a:p>

</xml_diff>